<commit_message>
Add token usage slide to presentation
Co-Authored-By: Claude Sonnet 4.6 <noreply@anthropic.com>
</commit_message>
<xml_diff>
--- a/docs/WeatheryApp_Presentation.pptx
+++ b/docs/WeatheryApp_Presentation.pptx
@@ -17,6 +17,7 @@
     <p:sldId id="265" r:id="rId16"/>
     <p:sldId id="266" r:id="rId17"/>
     <p:sldId id="267" r:id="rId18"/>
+    <p:sldId id="268" r:id="rId19"/>
   </p:sldIdLst>
   <p:sldSz cx="12188952" cy="6858000" type="screen4x3"/>
   <p:notesSz cx="6858000" cy="9144000"/>
@@ -3802,7 +3803,7 @@
                   <a:srgbClr val="993322"/>
                 </a:solidFill>
               </a:rPr>
-              <a:t>No native equivalent on Android</a:t>
+              <a:t>No native drawer equivalent on Android</a:t>
             </a:r>
           </a:p>
         </p:txBody>
@@ -4226,6 +4227,844 @@
 </file>
 
 <file path=ppt/slides/slide11.xml><?xml version="1.0" encoding="utf-8"?>
+<p:sld xmlns:a="http://schemas.openxmlformats.org/drawingml/2006/main" xmlns:p="http://schemas.openxmlformats.org/presentationml/2006/main" xmlns:r="http://schemas.openxmlformats.org/officeDocument/2006/relationships">
+  <p:cSld>
+    <p:bg>
+      <p:bgPr>
+        <a:solidFill>
+          <a:srgbClr val="0E1E38"/>
+        </a:solidFill>
+        <a:effectLst/>
+      </p:bgPr>
+    </p:bg>
+    <p:spTree>
+      <p:nvGrpSpPr>
+        <p:cNvPr id="1" name=""/>
+        <p:cNvGrpSpPr/>
+        <p:nvPr/>
+      </p:nvGrpSpPr>
+      <p:grpSpPr/>
+      <p:sp>
+        <p:nvSpPr>
+          <p:cNvPr id="2" name="Rectangle 1"/>
+          <p:cNvSpPr/>
+          <p:nvPr/>
+        </p:nvSpPr>
+        <p:spPr>
+          <a:xfrm>
+            <a:off x="0" y="0"/>
+            <a:ext cx="12188952" cy="1097280"/>
+          </a:xfrm>
+          <a:prstGeom prst="rect">
+            <a:avLst/>
+          </a:prstGeom>
+          <a:solidFill>
+            <a:srgbClr val="0E1E38"/>
+          </a:solidFill>
+          <a:ln>
+            <a:noFill/>
+          </a:ln>
+        </p:spPr>
+        <p:style>
+          <a:lnRef idx="1">
+            <a:schemeClr val="accent1"/>
+          </a:lnRef>
+          <a:fillRef idx="3">
+            <a:schemeClr val="accent1"/>
+          </a:fillRef>
+          <a:effectRef idx="2">
+            <a:schemeClr val="accent1"/>
+          </a:effectRef>
+          <a:fontRef idx="minor">
+            <a:schemeClr val="lt1"/>
+          </a:fontRef>
+        </p:style>
+        <p:txBody>
+          <a:bodyPr rtlCol="0" anchor="ctr"/>
+          <a:lstStyle/>
+          <a:p>
+            <a:pPr algn="ctr"/>
+          </a:p>
+        </p:txBody>
+      </p:sp>
+      <p:sp>
+        <p:nvSpPr>
+          <p:cNvPr id="3" name="TextBox 2"/>
+          <p:cNvSpPr txBox="1"/>
+          <p:nvPr/>
+        </p:nvSpPr>
+        <p:spPr>
+          <a:xfrm>
+            <a:off x="411480" y="201168"/>
+            <a:ext cx="11430000" cy="777240"/>
+          </a:xfrm>
+          <a:prstGeom prst="rect">
+            <a:avLst/>
+          </a:prstGeom>
+          <a:noFill/>
+        </p:spPr>
+        <p:txBody>
+          <a:bodyPr wrap="square">
+            <a:spAutoFit/>
+          </a:bodyPr>
+          <a:lstStyle/>
+          <a:p>
+            <a:pPr algn="l"/>
+            <a:r>
+              <a:rPr sz="3200" b="1" i="0">
+                <a:solidFill>
+                  <a:srgbClr val="FFFFFF"/>
+                </a:solidFill>
+              </a:rPr>
+              <a:t>Token Usage  --  Across All Sessions</a:t>
+            </a:r>
+          </a:p>
+        </p:txBody>
+      </p:sp>
+      <p:sp>
+        <p:nvSpPr>
+          <p:cNvPr id="4" name="TextBox 3"/>
+          <p:cNvSpPr txBox="1"/>
+          <p:nvPr/>
+        </p:nvSpPr>
+        <p:spPr>
+          <a:xfrm>
+            <a:off x="411480" y="1115568"/>
+            <a:ext cx="11338560" cy="365760"/>
+          </a:xfrm>
+          <a:prstGeom prst="rect">
+            <a:avLst/>
+          </a:prstGeom>
+          <a:noFill/>
+        </p:spPr>
+        <p:txBody>
+          <a:bodyPr wrap="square">
+            <a:spAutoFit/>
+          </a:bodyPr>
+          <a:lstStyle/>
+          <a:p>
+            <a:pPr algn="l"/>
+            <a:r>
+              <a:rPr sz="1500" b="0" i="1">
+                <a:solidFill>
+                  <a:srgbClr val="9999AA"/>
+                </a:solidFill>
+              </a:rPr>
+              <a:t>Real data from 4 Claude Code sessions  |  Measured from session logs</a:t>
+            </a:r>
+          </a:p>
+        </p:txBody>
+      </p:sp>
+      <p:sp>
+        <p:nvSpPr>
+          <p:cNvPr id="5" name="Rectangle 4"/>
+          <p:cNvSpPr/>
+          <p:nvPr/>
+        </p:nvSpPr>
+        <p:spPr>
+          <a:xfrm>
+            <a:off x="320040" y="1572768"/>
+            <a:ext cx="5029200" cy="3017520"/>
+          </a:xfrm>
+          <a:prstGeom prst="rect">
+            <a:avLst/>
+          </a:prstGeom>
+          <a:solidFill>
+            <a:srgbClr val="4A90E2"/>
+          </a:solidFill>
+          <a:ln>
+            <a:noFill/>
+          </a:ln>
+        </p:spPr>
+        <p:style>
+          <a:lnRef idx="1">
+            <a:schemeClr val="accent1"/>
+          </a:lnRef>
+          <a:fillRef idx="3">
+            <a:schemeClr val="accent1"/>
+          </a:fillRef>
+          <a:effectRef idx="2">
+            <a:schemeClr val="accent1"/>
+          </a:effectRef>
+          <a:fontRef idx="minor">
+            <a:schemeClr val="lt1"/>
+          </a:fontRef>
+        </p:style>
+        <p:txBody>
+          <a:bodyPr rtlCol="0" anchor="ctr"/>
+          <a:lstStyle/>
+          <a:p>
+            <a:pPr algn="ctr"/>
+          </a:p>
+        </p:txBody>
+      </p:sp>
+      <p:sp>
+        <p:nvSpPr>
+          <p:cNvPr id="6" name="TextBox 5"/>
+          <p:cNvSpPr txBox="1"/>
+          <p:nvPr/>
+        </p:nvSpPr>
+        <p:spPr>
+          <a:xfrm>
+            <a:off x="320040" y="1664208"/>
+            <a:ext cx="5029200" cy="1280160"/>
+          </a:xfrm>
+          <a:prstGeom prst="rect">
+            <a:avLst/>
+          </a:prstGeom>
+          <a:noFill/>
+        </p:spPr>
+        <p:txBody>
+          <a:bodyPr wrap="square">
+            <a:spAutoFit/>
+          </a:bodyPr>
+          <a:lstStyle/>
+          <a:p>
+            <a:pPr algn="ctr"/>
+            <a:r>
+              <a:rPr sz="5200" b="1" i="0">
+                <a:solidFill>
+                  <a:srgbClr val="FFFFFF"/>
+                </a:solidFill>
+              </a:rPr>
+              <a:t>10,022,333</a:t>
+            </a:r>
+          </a:p>
+        </p:txBody>
+      </p:sp>
+      <p:sp>
+        <p:nvSpPr>
+          <p:cNvPr id="7" name="TextBox 6"/>
+          <p:cNvSpPr txBox="1"/>
+          <p:nvPr/>
+        </p:nvSpPr>
+        <p:spPr>
+          <a:xfrm>
+            <a:off x="320040" y="2834640"/>
+            <a:ext cx="5029200" cy="457200"/>
+          </a:xfrm>
+          <a:prstGeom prst="rect">
+            <a:avLst/>
+          </a:prstGeom>
+          <a:noFill/>
+        </p:spPr>
+        <p:txBody>
+          <a:bodyPr wrap="square">
+            <a:spAutoFit/>
+          </a:bodyPr>
+          <a:lstStyle/>
+          <a:p>
+            <a:pPr algn="ctr"/>
+            <a:r>
+              <a:rPr sz="1800" b="0" i="0">
+                <a:solidFill>
+                  <a:srgbClr val="CCE5FF"/>
+                </a:solidFill>
+              </a:rPr>
+              <a:t>Total Tokens Processed</a:t>
+            </a:r>
+          </a:p>
+        </p:txBody>
+      </p:sp>
+      <p:sp>
+        <p:nvSpPr>
+          <p:cNvPr id="8" name="TextBox 7"/>
+          <p:cNvSpPr txBox="1"/>
+          <p:nvPr/>
+        </p:nvSpPr>
+        <p:spPr>
+          <a:xfrm>
+            <a:off x="320040" y="3273552"/>
+            <a:ext cx="5029200" cy="329184"/>
+          </a:xfrm>
+          <a:prstGeom prst="rect">
+            <a:avLst/>
+          </a:prstGeom>
+          <a:noFill/>
+        </p:spPr>
+        <p:txBody>
+          <a:bodyPr wrap="square">
+            <a:spAutoFit/>
+          </a:bodyPr>
+          <a:lstStyle/>
+          <a:p>
+            <a:pPr algn="ctr"/>
+            <a:r>
+              <a:rPr sz="1400" b="0" i="1">
+                <a:solidFill>
+                  <a:srgbClr val="AACCFF"/>
+                </a:solidFill>
+              </a:rPr>
+              <a:t>(including cache)</a:t>
+            </a:r>
+          </a:p>
+        </p:txBody>
+      </p:sp>
+      <p:sp>
+        <p:nvSpPr>
+          <p:cNvPr id="9" name="Rectangle 8"/>
+          <p:cNvSpPr/>
+          <p:nvPr/>
+        </p:nvSpPr>
+        <p:spPr>
+          <a:xfrm>
+            <a:off x="5577840" y="1572768"/>
+            <a:ext cx="3246120" cy="1298448"/>
+          </a:xfrm>
+          <a:prstGeom prst="rect">
+            <a:avLst/>
+          </a:prstGeom>
+          <a:solidFill>
+            <a:srgbClr val="1A6B3C"/>
+          </a:solidFill>
+          <a:ln>
+            <a:noFill/>
+          </a:ln>
+        </p:spPr>
+        <p:style>
+          <a:lnRef idx="1">
+            <a:schemeClr val="accent1"/>
+          </a:lnRef>
+          <a:fillRef idx="3">
+            <a:schemeClr val="accent1"/>
+          </a:fillRef>
+          <a:effectRef idx="2">
+            <a:schemeClr val="accent1"/>
+          </a:effectRef>
+          <a:fontRef idx="minor">
+            <a:schemeClr val="lt1"/>
+          </a:fontRef>
+        </p:style>
+        <p:txBody>
+          <a:bodyPr rtlCol="0" anchor="ctr"/>
+          <a:lstStyle/>
+          <a:p>
+            <a:pPr algn="ctr"/>
+          </a:p>
+        </p:txBody>
+      </p:sp>
+      <p:sp>
+        <p:nvSpPr>
+          <p:cNvPr id="10" name="TextBox 9"/>
+          <p:cNvSpPr txBox="1"/>
+          <p:nvPr/>
+        </p:nvSpPr>
+        <p:spPr>
+          <a:xfrm>
+            <a:off x="5577840" y="1682496"/>
+            <a:ext cx="3246120" cy="685800"/>
+          </a:xfrm>
+          <a:prstGeom prst="rect">
+            <a:avLst/>
+          </a:prstGeom>
+          <a:noFill/>
+        </p:spPr>
+        <p:txBody>
+          <a:bodyPr wrap="square">
+            <a:spAutoFit/>
+          </a:bodyPr>
+          <a:lstStyle/>
+          <a:p>
+            <a:pPr algn="ctr"/>
+            <a:r>
+              <a:rPr sz="3000" b="1" i="0">
+                <a:solidFill>
+                  <a:srgbClr val="A8FFC8"/>
+                </a:solidFill>
+              </a:rPr>
+              <a:t>9,094,592</a:t>
+            </a:r>
+          </a:p>
+        </p:txBody>
+      </p:sp>
+      <p:sp>
+        <p:nvSpPr>
+          <p:cNvPr id="11" name="TextBox 10"/>
+          <p:cNvSpPr txBox="1"/>
+          <p:nvPr/>
+        </p:nvSpPr>
+        <p:spPr>
+          <a:xfrm>
+            <a:off x="5577840" y="2377440"/>
+            <a:ext cx="3246120" cy="420624"/>
+          </a:xfrm>
+          <a:prstGeom prst="rect">
+            <a:avLst/>
+          </a:prstGeom>
+          <a:noFill/>
+        </p:spPr>
+        <p:txBody>
+          <a:bodyPr wrap="square">
+            <a:spAutoFit/>
+          </a:bodyPr>
+          <a:lstStyle/>
+          <a:p>
+            <a:pPr algn="ctr"/>
+            <a:r>
+              <a:rPr sz="1400" b="0" i="0">
+                <a:solidFill>
+                  <a:srgbClr val="FFFFFF"/>
+                </a:solidFill>
+              </a:rPr>
+              <a:t>Cache Read Tokens</a:t>
+            </a:r>
+          </a:p>
+        </p:txBody>
+      </p:sp>
+      <p:sp>
+        <p:nvSpPr>
+          <p:cNvPr id="12" name="Rectangle 11"/>
+          <p:cNvSpPr/>
+          <p:nvPr/>
+        </p:nvSpPr>
+        <p:spPr>
+          <a:xfrm>
+            <a:off x="9025128" y="1572768"/>
+            <a:ext cx="3246120" cy="1298448"/>
+          </a:xfrm>
+          <a:prstGeom prst="rect">
+            <a:avLst/>
+          </a:prstGeom>
+          <a:solidFill>
+            <a:srgbClr val="5B2D8E"/>
+          </a:solidFill>
+          <a:ln>
+            <a:noFill/>
+          </a:ln>
+        </p:spPr>
+        <p:style>
+          <a:lnRef idx="1">
+            <a:schemeClr val="accent1"/>
+          </a:lnRef>
+          <a:fillRef idx="3">
+            <a:schemeClr val="accent1"/>
+          </a:fillRef>
+          <a:effectRef idx="2">
+            <a:schemeClr val="accent1"/>
+          </a:effectRef>
+          <a:fontRef idx="minor">
+            <a:schemeClr val="lt1"/>
+          </a:fontRef>
+        </p:style>
+        <p:txBody>
+          <a:bodyPr rtlCol="0" anchor="ctr"/>
+          <a:lstStyle/>
+          <a:p>
+            <a:pPr algn="ctr"/>
+          </a:p>
+        </p:txBody>
+      </p:sp>
+      <p:sp>
+        <p:nvSpPr>
+          <p:cNvPr id="13" name="TextBox 12"/>
+          <p:cNvSpPr txBox="1"/>
+          <p:nvPr/>
+        </p:nvSpPr>
+        <p:spPr>
+          <a:xfrm>
+            <a:off x="9025128" y="1682496"/>
+            <a:ext cx="3246120" cy="685800"/>
+          </a:xfrm>
+          <a:prstGeom prst="rect">
+            <a:avLst/>
+          </a:prstGeom>
+          <a:noFill/>
+        </p:spPr>
+        <p:txBody>
+          <a:bodyPr wrap="square">
+            <a:spAutoFit/>
+          </a:bodyPr>
+          <a:lstStyle/>
+          <a:p>
+            <a:pPr algn="ctr"/>
+            <a:r>
+              <a:rPr sz="3000" b="1" i="0">
+                <a:solidFill>
+                  <a:srgbClr val="DDBBFF"/>
+                </a:solidFill>
+              </a:rPr>
+              <a:t>584,219</a:t>
+            </a:r>
+          </a:p>
+        </p:txBody>
+      </p:sp>
+      <p:sp>
+        <p:nvSpPr>
+          <p:cNvPr id="14" name="TextBox 13"/>
+          <p:cNvSpPr txBox="1"/>
+          <p:nvPr/>
+        </p:nvSpPr>
+        <p:spPr>
+          <a:xfrm>
+            <a:off x="9025128" y="2377440"/>
+            <a:ext cx="3246120" cy="420624"/>
+          </a:xfrm>
+          <a:prstGeom prst="rect">
+            <a:avLst/>
+          </a:prstGeom>
+          <a:noFill/>
+        </p:spPr>
+        <p:txBody>
+          <a:bodyPr wrap="square">
+            <a:spAutoFit/>
+          </a:bodyPr>
+          <a:lstStyle/>
+          <a:p>
+            <a:pPr algn="ctr"/>
+            <a:r>
+              <a:rPr sz="1400" b="0" i="0">
+                <a:solidFill>
+                  <a:srgbClr val="FFFFFF"/>
+                </a:solidFill>
+              </a:rPr>
+              <a:t>Cache Write Tokens</a:t>
+            </a:r>
+          </a:p>
+        </p:txBody>
+      </p:sp>
+      <p:sp>
+        <p:nvSpPr>
+          <p:cNvPr id="15" name="Rectangle 14"/>
+          <p:cNvSpPr/>
+          <p:nvPr/>
+        </p:nvSpPr>
+        <p:spPr>
+          <a:xfrm>
+            <a:off x="5577840" y="3017520"/>
+            <a:ext cx="3246120" cy="1298448"/>
+          </a:xfrm>
+          <a:prstGeom prst="rect">
+            <a:avLst/>
+          </a:prstGeom>
+          <a:solidFill>
+            <a:srgbClr val="B84600"/>
+          </a:solidFill>
+          <a:ln>
+            <a:noFill/>
+          </a:ln>
+        </p:spPr>
+        <p:style>
+          <a:lnRef idx="1">
+            <a:schemeClr val="accent1"/>
+          </a:lnRef>
+          <a:fillRef idx="3">
+            <a:schemeClr val="accent1"/>
+          </a:fillRef>
+          <a:effectRef idx="2">
+            <a:schemeClr val="accent1"/>
+          </a:effectRef>
+          <a:fontRef idx="minor">
+            <a:schemeClr val="lt1"/>
+          </a:fontRef>
+        </p:style>
+        <p:txBody>
+          <a:bodyPr rtlCol="0" anchor="ctr"/>
+          <a:lstStyle/>
+          <a:p>
+            <a:pPr algn="ctr"/>
+          </a:p>
+        </p:txBody>
+      </p:sp>
+      <p:sp>
+        <p:nvSpPr>
+          <p:cNvPr id="16" name="TextBox 15"/>
+          <p:cNvSpPr txBox="1"/>
+          <p:nvPr/>
+        </p:nvSpPr>
+        <p:spPr>
+          <a:xfrm>
+            <a:off x="5577840" y="3127248"/>
+            <a:ext cx="3246120" cy="685800"/>
+          </a:xfrm>
+          <a:prstGeom prst="rect">
+            <a:avLst/>
+          </a:prstGeom>
+          <a:noFill/>
+        </p:spPr>
+        <p:txBody>
+          <a:bodyPr wrap="square">
+            <a:spAutoFit/>
+          </a:bodyPr>
+          <a:lstStyle/>
+          <a:p>
+            <a:pPr algn="ctr"/>
+            <a:r>
+              <a:rPr sz="3000" b="1" i="0">
+                <a:solidFill>
+                  <a:srgbClr val="FFCC88"/>
+                </a:solidFill>
+              </a:rPr>
+              <a:t>343,087</a:t>
+            </a:r>
+          </a:p>
+        </p:txBody>
+      </p:sp>
+      <p:sp>
+        <p:nvSpPr>
+          <p:cNvPr id="17" name="TextBox 16"/>
+          <p:cNvSpPr txBox="1"/>
+          <p:nvPr/>
+        </p:nvSpPr>
+        <p:spPr>
+          <a:xfrm>
+            <a:off x="5577840" y="3822192"/>
+            <a:ext cx="3246120" cy="420624"/>
+          </a:xfrm>
+          <a:prstGeom prst="rect">
+            <a:avLst/>
+          </a:prstGeom>
+          <a:noFill/>
+        </p:spPr>
+        <p:txBody>
+          <a:bodyPr wrap="square">
+            <a:spAutoFit/>
+          </a:bodyPr>
+          <a:lstStyle/>
+          <a:p>
+            <a:pPr algn="ctr"/>
+            <a:r>
+              <a:rPr sz="1400" b="0" i="0">
+                <a:solidFill>
+                  <a:srgbClr val="FFFFFF"/>
+                </a:solidFill>
+              </a:rPr>
+              <a:t>Output Tokens
+(Claude responses)</a:t>
+            </a:r>
+          </a:p>
+        </p:txBody>
+      </p:sp>
+      <p:sp>
+        <p:nvSpPr>
+          <p:cNvPr id="18" name="Rectangle 17"/>
+          <p:cNvSpPr/>
+          <p:nvPr/>
+        </p:nvSpPr>
+        <p:spPr>
+          <a:xfrm>
+            <a:off x="9025128" y="3017520"/>
+            <a:ext cx="3246120" cy="1298448"/>
+          </a:xfrm>
+          <a:prstGeom prst="rect">
+            <a:avLst/>
+          </a:prstGeom>
+          <a:solidFill>
+            <a:srgbClr val="1C3557"/>
+          </a:solidFill>
+          <a:ln>
+            <a:noFill/>
+          </a:ln>
+        </p:spPr>
+        <p:style>
+          <a:lnRef idx="1">
+            <a:schemeClr val="accent1"/>
+          </a:lnRef>
+          <a:fillRef idx="3">
+            <a:schemeClr val="accent1"/>
+          </a:fillRef>
+          <a:effectRef idx="2">
+            <a:schemeClr val="accent1"/>
+          </a:effectRef>
+          <a:fontRef idx="minor">
+            <a:schemeClr val="lt1"/>
+          </a:fontRef>
+        </p:style>
+        <p:txBody>
+          <a:bodyPr rtlCol="0" anchor="ctr"/>
+          <a:lstStyle/>
+          <a:p>
+            <a:pPr algn="ctr"/>
+          </a:p>
+        </p:txBody>
+      </p:sp>
+      <p:sp>
+        <p:nvSpPr>
+          <p:cNvPr id="19" name="TextBox 18"/>
+          <p:cNvSpPr txBox="1"/>
+          <p:nvPr/>
+        </p:nvSpPr>
+        <p:spPr>
+          <a:xfrm>
+            <a:off x="9025128" y="3127248"/>
+            <a:ext cx="3246120" cy="685800"/>
+          </a:xfrm>
+          <a:prstGeom prst="rect">
+            <a:avLst/>
+          </a:prstGeom>
+          <a:noFill/>
+        </p:spPr>
+        <p:txBody>
+          <a:bodyPr wrap="square">
+            <a:spAutoFit/>
+          </a:bodyPr>
+          <a:lstStyle/>
+          <a:p>
+            <a:pPr algn="ctr"/>
+            <a:r>
+              <a:rPr sz="3000" b="1" i="0">
+                <a:solidFill>
+                  <a:srgbClr val="AACCFF"/>
+                </a:solidFill>
+              </a:rPr>
+              <a:t>435</a:t>
+            </a:r>
+          </a:p>
+        </p:txBody>
+      </p:sp>
+      <p:sp>
+        <p:nvSpPr>
+          <p:cNvPr id="20" name="TextBox 19"/>
+          <p:cNvSpPr txBox="1"/>
+          <p:nvPr/>
+        </p:nvSpPr>
+        <p:spPr>
+          <a:xfrm>
+            <a:off x="9025128" y="3822192"/>
+            <a:ext cx="3246120" cy="420624"/>
+          </a:xfrm>
+          <a:prstGeom prst="rect">
+            <a:avLst/>
+          </a:prstGeom>
+          <a:noFill/>
+        </p:spPr>
+        <p:txBody>
+          <a:bodyPr wrap="square">
+            <a:spAutoFit/>
+          </a:bodyPr>
+          <a:lstStyle/>
+          <a:p>
+            <a:pPr algn="ctr"/>
+            <a:r>
+              <a:rPr sz="1400" b="0" i="0">
+                <a:solidFill>
+                  <a:srgbClr val="FFFFFF"/>
+                </a:solidFill>
+              </a:rPr>
+              <a:t>Fresh Input Tokens</a:t>
+            </a:r>
+          </a:p>
+        </p:txBody>
+      </p:sp>
+      <p:sp>
+        <p:nvSpPr>
+          <p:cNvPr id="21" name="Rectangle 20"/>
+          <p:cNvSpPr/>
+          <p:nvPr/>
+        </p:nvSpPr>
+        <p:spPr>
+          <a:xfrm>
+            <a:off x="320040" y="4773168"/>
+            <a:ext cx="11548872" cy="1371600"/>
+          </a:xfrm>
+          <a:prstGeom prst="rect">
+            <a:avLst/>
+          </a:prstGeom>
+          <a:solidFill>
+            <a:srgbClr val="162A48"/>
+          </a:solidFill>
+          <a:ln>
+            <a:noFill/>
+          </a:ln>
+        </p:spPr>
+        <p:style>
+          <a:lnRef idx="1">
+            <a:schemeClr val="accent1"/>
+          </a:lnRef>
+          <a:fillRef idx="3">
+            <a:schemeClr val="accent1"/>
+          </a:fillRef>
+          <a:effectRef idx="2">
+            <a:schemeClr val="accent1"/>
+          </a:effectRef>
+          <a:fontRef idx="minor">
+            <a:schemeClr val="lt1"/>
+          </a:fontRef>
+        </p:style>
+        <p:txBody>
+          <a:bodyPr rtlCol="0" anchor="ctr"/>
+          <a:lstStyle/>
+          <a:p>
+            <a:pPr algn="ctr"/>
+          </a:p>
+        </p:txBody>
+      </p:sp>
+      <p:sp>
+        <p:nvSpPr>
+          <p:cNvPr id="22" name="TextBox 21"/>
+          <p:cNvSpPr txBox="1"/>
+          <p:nvPr/>
+        </p:nvSpPr>
+        <p:spPr>
+          <a:xfrm>
+            <a:off x="502920" y="4864608"/>
+            <a:ext cx="11201400" cy="438912"/>
+          </a:xfrm>
+          <a:prstGeom prst="rect">
+            <a:avLst/>
+          </a:prstGeom>
+          <a:noFill/>
+        </p:spPr>
+        <p:txBody>
+          <a:bodyPr wrap="square">
+            <a:spAutoFit/>
+          </a:bodyPr>
+          <a:lstStyle/>
+          <a:p>
+            <a:pPr algn="l"/>
+            <a:r>
+              <a:rPr sz="1700" b="1" i="0">
+                <a:solidFill>
+                  <a:srgbClr val="4A90E2"/>
+                </a:solidFill>
+              </a:rPr>
+              <a:t>92% of all tokens came from cache  --  showing how efficiently Claude reused context across turns</a:t>
+            </a:r>
+          </a:p>
+        </p:txBody>
+      </p:sp>
+      <p:sp>
+        <p:nvSpPr>
+          <p:cNvPr id="23" name="TextBox 22"/>
+          <p:cNvSpPr txBox="1"/>
+          <p:nvPr/>
+        </p:nvSpPr>
+        <p:spPr>
+          <a:xfrm>
+            <a:off x="502920" y="5321808"/>
+            <a:ext cx="11201400" cy="685800"/>
+          </a:xfrm>
+          <a:prstGeom prst="rect">
+            <a:avLst/>
+          </a:prstGeom>
+          <a:noFill/>
+        </p:spPr>
+        <p:txBody>
+          <a:bodyPr wrap="square">
+            <a:spAutoFit/>
+          </a:bodyPr>
+          <a:lstStyle/>
+          <a:p>
+            <a:pPr algn="l"/>
+            <a:r>
+              <a:rPr sz="1500" b="0" i="0">
+                <a:solidFill>
+                  <a:srgbClr val="B0C8E8"/>
+                </a:solidFill>
+              </a:rPr>
+              <a:t>Cache hits save processing time and cost. Output tokens (343K) represent all code, explanations and fixes generated by Claude.</a:t>
+            </a:r>
+          </a:p>
+        </p:txBody>
+      </p:sp>
+    </p:spTree>
+  </p:cSld>
+  <p:clrMapOvr>
+    <a:masterClrMapping/>
+  </p:clrMapOvr>
+</p:sld>
+</file>
+
+<file path=ppt/slides/slide12.xml><?xml version="1.0" encoding="utf-8"?>
 <p:sld xmlns:a="http://schemas.openxmlformats.org/drawingml/2006/main" xmlns:p="http://schemas.openxmlformats.org/presentationml/2006/main" xmlns:r="http://schemas.openxmlformats.org/officeDocument/2006/relationships">
   <p:cSld>
     <p:bg>
@@ -5262,7 +6101,7 @@
 </p:sld>
 </file>
 
-<file path=ppt/slides/slide12.xml><?xml version="1.0" encoding="utf-8"?>
+<file path=ppt/slides/slide13.xml><?xml version="1.0" encoding="utf-8"?>
 <p:sld xmlns:a="http://schemas.openxmlformats.org/drawingml/2006/main" xmlns:p="http://schemas.openxmlformats.org/presentationml/2006/main" xmlns:r="http://schemas.openxmlformats.org/officeDocument/2006/relationships">
   <p:cSld>
     <p:bg>
@@ -6519,7 +7358,7 @@
                   <a:srgbClr val="222233"/>
                 </a:solidFill>
               </a:rPr>
-              <a:t>  City search  +  ?C / ?F toggle</a:t>
+              <a:t>  City search  +  oC / oF toggle</a:t>
             </a:r>
           </a:p>
         </p:txBody>
@@ -9603,7 +10442,7 @@
                   <a:srgbClr val="222233"/>
                 </a:solidFill>
               </a:rPr>
-              <a:t>  City search  +  ?C / ?F toggle</a:t>
+              <a:t>  City search  +  oC / oF toggle</a:t>
             </a:r>
           </a:p>
           <a:p>
@@ -11035,7 +11874,7 @@
         <p:spPr>
           <a:xfrm>
             <a:off x="274320" y="1115568"/>
-            <a:ext cx="3291840" cy="484632"/>
+            <a:ext cx="3291840" cy="502920"/>
           </a:xfrm>
           <a:prstGeom prst="rect">
             <a:avLst/>
@@ -11078,7 +11917,7 @@
         <p:spPr>
           <a:xfrm>
             <a:off x="384048" y="1207008"/>
-            <a:ext cx="3145536" cy="393192"/>
+            <a:ext cx="3145536" cy="411480"/>
           </a:xfrm>
           <a:prstGeom prst="rect">
             <a:avLst/>
@@ -11112,7 +11951,7 @@
         <p:spPr>
           <a:xfrm>
             <a:off x="3611880" y="1115568"/>
-            <a:ext cx="3657600" cy="484632"/>
+            <a:ext cx="3657600" cy="502920"/>
           </a:xfrm>
           <a:prstGeom prst="rect">
             <a:avLst/>
@@ -11155,7 +11994,7 @@
         <p:spPr>
           <a:xfrm>
             <a:off x="3721608" y="1207008"/>
-            <a:ext cx="3511296" cy="393192"/>
+            <a:ext cx="3511296" cy="411480"/>
           </a:xfrm>
           <a:prstGeom prst="rect">
             <a:avLst/>
@@ -11189,7 +12028,7 @@
         <p:spPr>
           <a:xfrm>
             <a:off x="7315200" y="1115568"/>
-            <a:ext cx="4096512" cy="484632"/>
+            <a:ext cx="4096512" cy="502920"/>
           </a:xfrm>
           <a:prstGeom prst="rect">
             <a:avLst/>
@@ -11232,7 +12071,7 @@
         <p:spPr>
           <a:xfrm>
             <a:off x="7424928" y="1207008"/>
-            <a:ext cx="3950208" cy="393192"/>
+            <a:ext cx="3950208" cy="411480"/>
           </a:xfrm>
           <a:prstGeom prst="rect">
             <a:avLst/>
@@ -11265,8 +12104,8 @@
         </p:nvSpPr>
         <p:spPr>
           <a:xfrm>
-            <a:off x="274320" y="1600200"/>
-            <a:ext cx="3291840" cy="484632"/>
+            <a:off x="274320" y="1618488"/>
+            <a:ext cx="3291840" cy="502920"/>
           </a:xfrm>
           <a:prstGeom prst="rect">
             <a:avLst/>
@@ -11308,8 +12147,8 @@
         </p:nvSpPr>
         <p:spPr>
           <a:xfrm>
-            <a:off x="384048" y="1691640"/>
-            <a:ext cx="3145536" cy="393192"/>
+            <a:off x="384048" y="1709928"/>
+            <a:ext cx="3145536" cy="411480"/>
           </a:xfrm>
           <a:prstGeom prst="rect">
             <a:avLst/>
@@ -11342,8 +12181,8 @@
         </p:nvSpPr>
         <p:spPr>
           <a:xfrm>
-            <a:off x="3611880" y="1600200"/>
-            <a:ext cx="3657600" cy="484632"/>
+            <a:off x="3611880" y="1618488"/>
+            <a:ext cx="3657600" cy="502920"/>
           </a:xfrm>
           <a:prstGeom prst="rect">
             <a:avLst/>
@@ -11385,8 +12224,8 @@
         </p:nvSpPr>
         <p:spPr>
           <a:xfrm>
-            <a:off x="3721608" y="1691640"/>
-            <a:ext cx="3511296" cy="393192"/>
+            <a:off x="3721608" y="1709928"/>
+            <a:ext cx="3511296" cy="411480"/>
           </a:xfrm>
           <a:prstGeom prst="rect">
             <a:avLst/>
@@ -11419,8 +12258,8 @@
         </p:nvSpPr>
         <p:spPr>
           <a:xfrm>
-            <a:off x="7315200" y="1600200"/>
-            <a:ext cx="4096512" cy="484632"/>
+            <a:off x="7315200" y="1618488"/>
+            <a:ext cx="4096512" cy="502920"/>
           </a:xfrm>
           <a:prstGeom prst="rect">
             <a:avLst/>
@@ -11462,8 +12301,8 @@
         </p:nvSpPr>
         <p:spPr>
           <a:xfrm>
-            <a:off x="7424928" y="1691640"/>
-            <a:ext cx="3950208" cy="393192"/>
+            <a:off x="7424928" y="1709928"/>
+            <a:ext cx="3950208" cy="411480"/>
           </a:xfrm>
           <a:prstGeom prst="rect">
             <a:avLst/>
@@ -11496,8 +12335,8 @@
         </p:nvSpPr>
         <p:spPr>
           <a:xfrm>
-            <a:off x="274320" y="2084832"/>
-            <a:ext cx="3291840" cy="484632"/>
+            <a:off x="274320" y="2121408"/>
+            <a:ext cx="3291840" cy="502920"/>
           </a:xfrm>
           <a:prstGeom prst="rect">
             <a:avLst/>
@@ -11539,8 +12378,8 @@
         </p:nvSpPr>
         <p:spPr>
           <a:xfrm>
-            <a:off x="384048" y="2176272"/>
-            <a:ext cx="3145536" cy="393192"/>
+            <a:off x="384048" y="2212848"/>
+            <a:ext cx="3145536" cy="411480"/>
           </a:xfrm>
           <a:prstGeom prst="rect">
             <a:avLst/>
@@ -11573,8 +12412,8 @@
         </p:nvSpPr>
         <p:spPr>
           <a:xfrm>
-            <a:off x="3611880" y="2084832"/>
-            <a:ext cx="3657600" cy="484632"/>
+            <a:off x="3611880" y="2121408"/>
+            <a:ext cx="3657600" cy="502920"/>
           </a:xfrm>
           <a:prstGeom prst="rect">
             <a:avLst/>
@@ -11616,8 +12455,8 @@
         </p:nvSpPr>
         <p:spPr>
           <a:xfrm>
-            <a:off x="3721608" y="2176272"/>
-            <a:ext cx="3511296" cy="393192"/>
+            <a:off x="3721608" y="2212848"/>
+            <a:ext cx="3511296" cy="411480"/>
           </a:xfrm>
           <a:prstGeom prst="rect">
             <a:avLst/>
@@ -11650,8 +12489,8 @@
         </p:nvSpPr>
         <p:spPr>
           <a:xfrm>
-            <a:off x="7315200" y="2084832"/>
-            <a:ext cx="4096512" cy="484632"/>
+            <a:off x="7315200" y="2121408"/>
+            <a:ext cx="4096512" cy="502920"/>
           </a:xfrm>
           <a:prstGeom prst="rect">
             <a:avLst/>
@@ -11693,8 +12532,8 @@
         </p:nvSpPr>
         <p:spPr>
           <a:xfrm>
-            <a:off x="7424928" y="2176272"/>
-            <a:ext cx="3950208" cy="393192"/>
+            <a:off x="7424928" y="2212848"/>
+            <a:ext cx="3950208" cy="411480"/>
           </a:xfrm>
           <a:prstGeom prst="rect">
             <a:avLst/>
@@ -11727,8 +12566,8 @@
         </p:nvSpPr>
         <p:spPr>
           <a:xfrm>
-            <a:off x="274320" y="2569464"/>
-            <a:ext cx="3291840" cy="484632"/>
+            <a:off x="274320" y="2624328"/>
+            <a:ext cx="3291840" cy="502920"/>
           </a:xfrm>
           <a:prstGeom prst="rect">
             <a:avLst/>
@@ -11770,8 +12609,8 @@
         </p:nvSpPr>
         <p:spPr>
           <a:xfrm>
-            <a:off x="384048" y="2660904"/>
-            <a:ext cx="3145536" cy="393192"/>
+            <a:off x="384048" y="2715768"/>
+            <a:ext cx="3145536" cy="411480"/>
           </a:xfrm>
           <a:prstGeom prst="rect">
             <a:avLst/>
@@ -11804,8 +12643,8 @@
         </p:nvSpPr>
         <p:spPr>
           <a:xfrm>
-            <a:off x="3611880" y="2569464"/>
-            <a:ext cx="3657600" cy="484632"/>
+            <a:off x="3611880" y="2624328"/>
+            <a:ext cx="3657600" cy="502920"/>
           </a:xfrm>
           <a:prstGeom prst="rect">
             <a:avLst/>
@@ -11847,8 +12686,8 @@
         </p:nvSpPr>
         <p:spPr>
           <a:xfrm>
-            <a:off x="3721608" y="2660904"/>
-            <a:ext cx="3511296" cy="393192"/>
+            <a:off x="3721608" y="2715768"/>
+            <a:ext cx="3511296" cy="411480"/>
           </a:xfrm>
           <a:prstGeom prst="rect">
             <a:avLst/>
@@ -11881,8 +12720,8 @@
         </p:nvSpPr>
         <p:spPr>
           <a:xfrm>
-            <a:off x="7315200" y="2569464"/>
-            <a:ext cx="4096512" cy="484632"/>
+            <a:off x="7315200" y="2624328"/>
+            <a:ext cx="4096512" cy="502920"/>
           </a:xfrm>
           <a:prstGeom prst="rect">
             <a:avLst/>
@@ -11924,8 +12763,8 @@
         </p:nvSpPr>
         <p:spPr>
           <a:xfrm>
-            <a:off x="7424928" y="2660904"/>
-            <a:ext cx="3950208" cy="393192"/>
+            <a:off x="7424928" y="2715768"/>
+            <a:ext cx="3950208" cy="411480"/>
           </a:xfrm>
           <a:prstGeom prst="rect">
             <a:avLst/>
@@ -11958,8 +12797,8 @@
         </p:nvSpPr>
         <p:spPr>
           <a:xfrm>
-            <a:off x="274320" y="3054096"/>
-            <a:ext cx="3291840" cy="484632"/>
+            <a:off x="274320" y="3127248"/>
+            <a:ext cx="3291840" cy="502920"/>
           </a:xfrm>
           <a:prstGeom prst="rect">
             <a:avLst/>
@@ -12001,8 +12840,8 @@
         </p:nvSpPr>
         <p:spPr>
           <a:xfrm>
-            <a:off x="384048" y="3145536"/>
-            <a:ext cx="3145536" cy="393192"/>
+            <a:off x="384048" y="3218688"/>
+            <a:ext cx="3145536" cy="411480"/>
           </a:xfrm>
           <a:prstGeom prst="rect">
             <a:avLst/>
@@ -12035,8 +12874,8 @@
         </p:nvSpPr>
         <p:spPr>
           <a:xfrm>
-            <a:off x="3611880" y="3054096"/>
-            <a:ext cx="3657600" cy="484632"/>
+            <a:off x="3611880" y="3127248"/>
+            <a:ext cx="3657600" cy="502920"/>
           </a:xfrm>
           <a:prstGeom prst="rect">
             <a:avLst/>
@@ -12078,8 +12917,8 @@
         </p:nvSpPr>
         <p:spPr>
           <a:xfrm>
-            <a:off x="3721608" y="3145536"/>
-            <a:ext cx="3511296" cy="393192"/>
+            <a:off x="3721608" y="3218688"/>
+            <a:ext cx="3511296" cy="411480"/>
           </a:xfrm>
           <a:prstGeom prst="rect">
             <a:avLst/>
@@ -12112,8 +12951,8 @@
         </p:nvSpPr>
         <p:spPr>
           <a:xfrm>
-            <a:off x="7315200" y="3054096"/>
-            <a:ext cx="4096512" cy="484632"/>
+            <a:off x="7315200" y="3127248"/>
+            <a:ext cx="4096512" cy="502920"/>
           </a:xfrm>
           <a:prstGeom prst="rect">
             <a:avLst/>
@@ -12155,8 +12994,8 @@
         </p:nvSpPr>
         <p:spPr>
           <a:xfrm>
-            <a:off x="7424928" y="3145536"/>
-            <a:ext cx="3950208" cy="393192"/>
+            <a:off x="7424928" y="3218688"/>
+            <a:ext cx="3950208" cy="411480"/>
           </a:xfrm>
           <a:prstGeom prst="rect">
             <a:avLst/>
@@ -12189,8 +13028,8 @@
         </p:nvSpPr>
         <p:spPr>
           <a:xfrm>
-            <a:off x="274320" y="3538728"/>
-            <a:ext cx="3291840" cy="484632"/>
+            <a:off x="274320" y="3630168"/>
+            <a:ext cx="3291840" cy="502920"/>
           </a:xfrm>
           <a:prstGeom prst="rect">
             <a:avLst/>
@@ -12232,8 +13071,8 @@
         </p:nvSpPr>
         <p:spPr>
           <a:xfrm>
-            <a:off x="384048" y="3630168"/>
-            <a:ext cx="3145536" cy="393192"/>
+            <a:off x="384048" y="3721608"/>
+            <a:ext cx="3145536" cy="411480"/>
           </a:xfrm>
           <a:prstGeom prst="rect">
             <a:avLst/>
@@ -12266,8 +13105,8 @@
         </p:nvSpPr>
         <p:spPr>
           <a:xfrm>
-            <a:off x="3611880" y="3538728"/>
-            <a:ext cx="3657600" cy="484632"/>
+            <a:off x="3611880" y="3630168"/>
+            <a:ext cx="3657600" cy="502920"/>
           </a:xfrm>
           <a:prstGeom prst="rect">
             <a:avLst/>
@@ -12309,8 +13148,8 @@
         </p:nvSpPr>
         <p:spPr>
           <a:xfrm>
-            <a:off x="3721608" y="3630168"/>
-            <a:ext cx="3511296" cy="393192"/>
+            <a:off x="3721608" y="3721608"/>
+            <a:ext cx="3511296" cy="411480"/>
           </a:xfrm>
           <a:prstGeom prst="rect">
             <a:avLst/>
@@ -12343,8 +13182,8 @@
         </p:nvSpPr>
         <p:spPr>
           <a:xfrm>
-            <a:off x="7315200" y="3538728"/>
-            <a:ext cx="4096512" cy="484632"/>
+            <a:off x="7315200" y="3630168"/>
+            <a:ext cx="4096512" cy="502920"/>
           </a:xfrm>
           <a:prstGeom prst="rect">
             <a:avLst/>
@@ -12386,8 +13225,8 @@
         </p:nvSpPr>
         <p:spPr>
           <a:xfrm>
-            <a:off x="7424928" y="3630168"/>
-            <a:ext cx="3950208" cy="393192"/>
+            <a:off x="7424928" y="3721608"/>
+            <a:ext cx="3950208" cy="411480"/>
           </a:xfrm>
           <a:prstGeom prst="rect">
             <a:avLst/>
@@ -12420,8 +13259,8 @@
         </p:nvSpPr>
         <p:spPr>
           <a:xfrm>
-            <a:off x="274320" y="4023360"/>
-            <a:ext cx="3291840" cy="484632"/>
+            <a:off x="274320" y="4133088"/>
+            <a:ext cx="3291840" cy="502920"/>
           </a:xfrm>
           <a:prstGeom prst="rect">
             <a:avLst/>
@@ -12463,8 +13302,8 @@
         </p:nvSpPr>
         <p:spPr>
           <a:xfrm>
-            <a:off x="384048" y="4114800"/>
-            <a:ext cx="3145536" cy="393192"/>
+            <a:off x="384048" y="4224528"/>
+            <a:ext cx="3145536" cy="411480"/>
           </a:xfrm>
           <a:prstGeom prst="rect">
             <a:avLst/>
@@ -12497,8 +13336,8 @@
         </p:nvSpPr>
         <p:spPr>
           <a:xfrm>
-            <a:off x="3611880" y="4023360"/>
-            <a:ext cx="3657600" cy="484632"/>
+            <a:off x="3611880" y="4133088"/>
+            <a:ext cx="3657600" cy="502920"/>
           </a:xfrm>
           <a:prstGeom prst="rect">
             <a:avLst/>
@@ -12540,8 +13379,8 @@
         </p:nvSpPr>
         <p:spPr>
           <a:xfrm>
-            <a:off x="3721608" y="4114800"/>
-            <a:ext cx="3511296" cy="393192"/>
+            <a:off x="3721608" y="4224528"/>
+            <a:ext cx="3511296" cy="411480"/>
           </a:xfrm>
           <a:prstGeom prst="rect">
             <a:avLst/>
@@ -12574,8 +13413,8 @@
         </p:nvSpPr>
         <p:spPr>
           <a:xfrm>
-            <a:off x="7315200" y="4023360"/>
-            <a:ext cx="4096512" cy="484632"/>
+            <a:off x="7315200" y="4133088"/>
+            <a:ext cx="4096512" cy="502920"/>
           </a:xfrm>
           <a:prstGeom prst="rect">
             <a:avLst/>
@@ -12617,8 +13456,8 @@
         </p:nvSpPr>
         <p:spPr>
           <a:xfrm>
-            <a:off x="7424928" y="4114800"/>
-            <a:ext cx="3950208" cy="393192"/>
+            <a:off x="7424928" y="4224528"/>
+            <a:ext cx="3950208" cy="411480"/>
           </a:xfrm>
           <a:prstGeom prst="rect">
             <a:avLst/>
@@ -12651,8 +13490,8 @@
         </p:nvSpPr>
         <p:spPr>
           <a:xfrm>
-            <a:off x="274320" y="4507992"/>
-            <a:ext cx="3291840" cy="484632"/>
+            <a:off x="274320" y="4636008"/>
+            <a:ext cx="3291840" cy="502920"/>
           </a:xfrm>
           <a:prstGeom prst="rect">
             <a:avLst/>
@@ -12694,8 +13533,8 @@
         </p:nvSpPr>
         <p:spPr>
           <a:xfrm>
-            <a:off x="384048" y="4599432"/>
-            <a:ext cx="3145536" cy="393192"/>
+            <a:off x="384048" y="4727448"/>
+            <a:ext cx="3145536" cy="411480"/>
           </a:xfrm>
           <a:prstGeom prst="rect">
             <a:avLst/>
@@ -12728,8 +13567,8 @@
         </p:nvSpPr>
         <p:spPr>
           <a:xfrm>
-            <a:off x="3611880" y="4507992"/>
-            <a:ext cx="3657600" cy="484632"/>
+            <a:off x="3611880" y="4636008"/>
+            <a:ext cx="3657600" cy="502920"/>
           </a:xfrm>
           <a:prstGeom prst="rect">
             <a:avLst/>
@@ -12771,8 +13610,8 @@
         </p:nvSpPr>
         <p:spPr>
           <a:xfrm>
-            <a:off x="3721608" y="4599432"/>
-            <a:ext cx="3511296" cy="393192"/>
+            <a:off x="3721608" y="4727448"/>
+            <a:ext cx="3511296" cy="411480"/>
           </a:xfrm>
           <a:prstGeom prst="rect">
             <a:avLst/>
@@ -12805,8 +13644,8 @@
         </p:nvSpPr>
         <p:spPr>
           <a:xfrm>
-            <a:off x="7315200" y="4507992"/>
-            <a:ext cx="4096512" cy="484632"/>
+            <a:off x="7315200" y="4636008"/>
+            <a:ext cx="4096512" cy="502920"/>
           </a:xfrm>
           <a:prstGeom prst="rect">
             <a:avLst/>
@@ -12848,8 +13687,8 @@
         </p:nvSpPr>
         <p:spPr>
           <a:xfrm>
-            <a:off x="7424928" y="4599432"/>
-            <a:ext cx="3950208" cy="393192"/>
+            <a:off x="7424928" y="4727448"/>
+            <a:ext cx="3950208" cy="411480"/>
           </a:xfrm>
           <a:prstGeom prst="rect">
             <a:avLst/>
@@ -12882,8 +13721,8 @@
         </p:nvSpPr>
         <p:spPr>
           <a:xfrm>
-            <a:off x="274320" y="4992624"/>
-            <a:ext cx="3291840" cy="484632"/>
+            <a:off x="274320" y="5138928"/>
+            <a:ext cx="3291840" cy="502920"/>
           </a:xfrm>
           <a:prstGeom prst="rect">
             <a:avLst/>
@@ -12925,8 +13764,8 @@
         </p:nvSpPr>
         <p:spPr>
           <a:xfrm>
-            <a:off x="384048" y="5084064"/>
-            <a:ext cx="3145536" cy="393192"/>
+            <a:off x="384048" y="5230368"/>
+            <a:ext cx="3145536" cy="411480"/>
           </a:xfrm>
           <a:prstGeom prst="rect">
             <a:avLst/>
@@ -12959,8 +13798,8 @@
         </p:nvSpPr>
         <p:spPr>
           <a:xfrm>
-            <a:off x="3611880" y="4992624"/>
-            <a:ext cx="3657600" cy="484632"/>
+            <a:off x="3611880" y="5138928"/>
+            <a:ext cx="3657600" cy="502920"/>
           </a:xfrm>
           <a:prstGeom prst="rect">
             <a:avLst/>
@@ -13002,8 +13841,8 @@
         </p:nvSpPr>
         <p:spPr>
           <a:xfrm>
-            <a:off x="3721608" y="5084064"/>
-            <a:ext cx="3511296" cy="393192"/>
+            <a:off x="3721608" y="5230368"/>
+            <a:ext cx="3511296" cy="411480"/>
           </a:xfrm>
           <a:prstGeom prst="rect">
             <a:avLst/>
@@ -13036,8 +13875,8 @@
         </p:nvSpPr>
         <p:spPr>
           <a:xfrm>
-            <a:off x="7315200" y="4992624"/>
-            <a:ext cx="4096512" cy="484632"/>
+            <a:off x="7315200" y="5138928"/>
+            <a:ext cx="4096512" cy="502920"/>
           </a:xfrm>
           <a:prstGeom prst="rect">
             <a:avLst/>
@@ -13079,8 +13918,8 @@
         </p:nvSpPr>
         <p:spPr>
           <a:xfrm>
-            <a:off x="7424928" y="5084064"/>
-            <a:ext cx="3950208" cy="393192"/>
+            <a:off x="7424928" y="5230368"/>
+            <a:ext cx="3950208" cy="411480"/>
           </a:xfrm>
           <a:prstGeom prst="rect">
             <a:avLst/>
@@ -13113,8 +13952,8 @@
         </p:nvSpPr>
         <p:spPr>
           <a:xfrm>
-            <a:off x="274320" y="5477256"/>
-            <a:ext cx="3291840" cy="484632"/>
+            <a:off x="274320" y="5641848"/>
+            <a:ext cx="3291840" cy="502920"/>
           </a:xfrm>
           <a:prstGeom prst="rect">
             <a:avLst/>
@@ -13156,8 +13995,8 @@
         </p:nvSpPr>
         <p:spPr>
           <a:xfrm>
-            <a:off x="384048" y="5568696"/>
-            <a:ext cx="3145536" cy="393192"/>
+            <a:off x="384048" y="5733288"/>
+            <a:ext cx="3145536" cy="411480"/>
           </a:xfrm>
           <a:prstGeom prst="rect">
             <a:avLst/>
@@ -13190,8 +14029,8 @@
         </p:nvSpPr>
         <p:spPr>
           <a:xfrm>
-            <a:off x="3611880" y="5477256"/>
-            <a:ext cx="3657600" cy="484632"/>
+            <a:off x="3611880" y="5641848"/>
+            <a:ext cx="3657600" cy="502920"/>
           </a:xfrm>
           <a:prstGeom prst="rect">
             <a:avLst/>
@@ -13233,8 +14072,8 @@
         </p:nvSpPr>
         <p:spPr>
           <a:xfrm>
-            <a:off x="3721608" y="5568696"/>
-            <a:ext cx="3511296" cy="393192"/>
+            <a:off x="3721608" y="5733288"/>
+            <a:ext cx="3511296" cy="411480"/>
           </a:xfrm>
           <a:prstGeom prst="rect">
             <a:avLst/>
@@ -13267,8 +14106,8 @@
         </p:nvSpPr>
         <p:spPr>
           <a:xfrm>
-            <a:off x="7315200" y="5477256"/>
-            <a:ext cx="4096512" cy="484632"/>
+            <a:off x="7315200" y="5641848"/>
+            <a:ext cx="4096512" cy="502920"/>
           </a:xfrm>
           <a:prstGeom prst="rect">
             <a:avLst/>
@@ -13310,8 +14149,8 @@
         </p:nvSpPr>
         <p:spPr>
           <a:xfrm>
-            <a:off x="7424928" y="5568696"/>
-            <a:ext cx="3950208" cy="393192"/>
+            <a:off x="7424928" y="5733288"/>
+            <a:ext cx="3950208" cy="411480"/>
           </a:xfrm>
           <a:prstGeom prst="rect">
             <a:avLst/>

</xml_diff>

<commit_message>
wer das liest ist ein
</commit_message>
<xml_diff>
--- a/docs/WeatheryApp_Presentation.pptx
+++ b/docs/WeatheryApp_Presentation.pptx
@@ -15,10 +15,9 @@
     <p:sldId id="263" r:id="rId9"/>
     <p:sldId id="264" r:id="rId10"/>
     <p:sldId id="269" r:id="rId11"/>
-    <p:sldId id="266" r:id="rId12"/>
-    <p:sldId id="265" r:id="rId13"/>
-    <p:sldId id="267" r:id="rId14"/>
-    <p:sldId id="268" r:id="rId15"/>
+    <p:sldId id="265" r:id="rId12"/>
+    <p:sldId id="267" r:id="rId13"/>
+    <p:sldId id="268" r:id="rId14"/>
   </p:sldIdLst>
   <p:sldSz cx="12188825" cy="6858000"/>
   <p:notesSz cx="6858000" cy="9144000"/>
@@ -4215,12 +4214,12 @@
 </file>
 
 <file path=ppt/slides/slide11.xml><?xml version="1.0" encoding="utf-8"?>
-<p:sld xmlns:a="http://schemas.openxmlformats.org/drawingml/2006/main" xmlns:r="http://schemas.openxmlformats.org/officeDocument/2006/relationships" xmlns:p="http://schemas.openxmlformats.org/presentationml/2006/main" show="0">
+<p:sld xmlns:a="http://schemas.openxmlformats.org/drawingml/2006/main" xmlns:r="http://schemas.openxmlformats.org/officeDocument/2006/relationships" xmlns:p="http://schemas.openxmlformats.org/presentationml/2006/main">
   <p:cSld>
     <p:bg>
       <p:bgPr>
         <a:solidFill>
-          <a:srgbClr val="0E1E38"/>
+          <a:srgbClr val="FFFFFF"/>
         </a:solidFill>
         <a:effectLst/>
       </p:bgPr>
@@ -4254,7 +4253,7 @@
             <a:avLst/>
           </a:prstGeom>
           <a:solidFill>
-            <a:srgbClr val="0E1E38"/>
+            <a:srgbClr val="1C3557"/>
           </a:solidFill>
           <a:ln>
             <a:noFill/>
@@ -4312,21 +4311,109 @@
                   <a:srgbClr val="FFFFFF"/>
                 </a:solidFill>
               </a:rPr>
-              <a:t>Token Usage  --  Across All Sessions</a:t>
-            </a:r>
-          </a:p>
-        </p:txBody>
-      </p:sp>
-      <p:sp>
-        <p:nvSpPr>
-          <p:cNvPr id="4" name="TextBox 3"/>
+              <a:t>Key Challenges</a:t>
+            </a:r>
+          </a:p>
+        </p:txBody>
+      </p:sp>
+      <p:sp>
+        <p:nvSpPr>
+          <p:cNvPr id="4" name="Rectangle 3"/>
+          <p:cNvSpPr/>
+          <p:nvPr/>
+        </p:nvSpPr>
+        <p:spPr>
+          <a:xfrm>
+            <a:off x="274320" y="1170432"/>
+            <a:ext cx="5669280" cy="1920240"/>
+          </a:xfrm>
+          <a:prstGeom prst="rect">
+            <a:avLst/>
+          </a:prstGeom>
+          <a:solidFill>
+            <a:srgbClr val="F4F6F9"/>
+          </a:solidFill>
+          <a:ln>
+            <a:noFill/>
+          </a:ln>
+        </p:spPr>
+        <p:style>
+          <a:lnRef idx="1">
+            <a:schemeClr val="accent1"/>
+          </a:lnRef>
+          <a:fillRef idx="3">
+            <a:schemeClr val="accent1"/>
+          </a:fillRef>
+          <a:effectRef idx="2">
+            <a:schemeClr val="accent1"/>
+          </a:effectRef>
+          <a:fontRef idx="minor">
+            <a:schemeClr val="lt1"/>
+          </a:fontRef>
+        </p:style>
+        <p:txBody>
+          <a:bodyPr rtlCol="0" anchor="ctr"/>
+          <a:lstStyle/>
+          <a:p>
+            <a:pPr algn="ctr"/>
+            <a:endParaRPr/>
+          </a:p>
+        </p:txBody>
+      </p:sp>
+      <p:sp>
+        <p:nvSpPr>
+          <p:cNvPr id="5" name="Rectangle 4"/>
+          <p:cNvSpPr/>
+          <p:nvPr/>
+        </p:nvSpPr>
+        <p:spPr>
+          <a:xfrm>
+            <a:off x="274320" y="1170432"/>
+            <a:ext cx="182880" cy="1920240"/>
+          </a:xfrm>
+          <a:prstGeom prst="rect">
+            <a:avLst/>
+          </a:prstGeom>
+          <a:solidFill>
+            <a:srgbClr val="E86A2C"/>
+          </a:solidFill>
+          <a:ln>
+            <a:noFill/>
+          </a:ln>
+        </p:spPr>
+        <p:style>
+          <a:lnRef idx="1">
+            <a:schemeClr val="accent1"/>
+          </a:lnRef>
+          <a:fillRef idx="3">
+            <a:schemeClr val="accent1"/>
+          </a:fillRef>
+          <a:effectRef idx="2">
+            <a:schemeClr val="accent1"/>
+          </a:effectRef>
+          <a:fontRef idx="minor">
+            <a:schemeClr val="lt1"/>
+          </a:fontRef>
+        </p:style>
+        <p:txBody>
+          <a:bodyPr rtlCol="0" anchor="ctr"/>
+          <a:lstStyle/>
+          <a:p>
+            <a:pPr algn="ctr"/>
+            <a:endParaRPr/>
+          </a:p>
+        </p:txBody>
+      </p:sp>
+      <p:sp>
+        <p:nvSpPr>
+          <p:cNvPr id="6" name="TextBox 5"/>
           <p:cNvSpPr txBox="1"/>
           <p:nvPr/>
         </p:nvSpPr>
         <p:spPr>
           <a:xfrm>
-            <a:off x="411480" y="1115568"/>
-            <a:ext cx="11338560" cy="365760"/>
+            <a:off x="566928" y="1280160"/>
+            <a:ext cx="5303520" cy="384048"/>
           </a:xfrm>
           <a:prstGeom prst="rect">
             <a:avLst/>
@@ -4341,26 +4428,138 @@
           <a:p>
             <a:pPr algn="l"/>
             <a:r>
-              <a:rPr sz="1500" b="0" i="1">
-                <a:solidFill>
-                  <a:srgbClr val="9999AA"/>
-                </a:solidFill>
-              </a:rPr>
-              <a:t>Real data from 4 Claude Code sessions  |  Measured from session logs</a:t>
-            </a:r>
-          </a:p>
-        </p:txBody>
-      </p:sp>
-      <p:sp>
-        <p:nvSpPr>
-          <p:cNvPr id="5" name="Rectangle 4"/>
+              <a:rPr sz="1700" b="1" i="0">
+                <a:solidFill>
+                  <a:srgbClr val="1C3557"/>
+                </a:solidFill>
+              </a:rPr>
+              <a:t>WeatherKit not on Android</a:t>
+            </a:r>
+          </a:p>
+        </p:txBody>
+      </p:sp>
+      <p:sp>
+        <p:nvSpPr>
+          <p:cNvPr id="7" name="TextBox 6"/>
+          <p:cNvSpPr txBox="1"/>
+          <p:nvPr/>
+        </p:nvSpPr>
+        <p:spPr>
+          <a:xfrm>
+            <a:off x="566928" y="1700784"/>
+            <a:ext cx="5303520" cy="457200"/>
+          </a:xfrm>
+          <a:prstGeom prst="rect">
+            <a:avLst/>
+          </a:prstGeom>
+          <a:noFill/>
+        </p:spPr>
+        <p:txBody>
+          <a:bodyPr wrap="square">
+            <a:spAutoFit/>
+          </a:bodyPr>
+          <a:lstStyle/>
+          <a:p>
+            <a:pPr algn="l"/>
+            <a:r>
+              <a:rPr sz="1600" b="0" i="1">
+                <a:solidFill>
+                  <a:srgbClr val="993322"/>
+                </a:solidFill>
+              </a:rPr>
+              <a:t>Apple-exclusive API</a:t>
+            </a:r>
+          </a:p>
+        </p:txBody>
+      </p:sp>
+      <p:sp>
+        <p:nvSpPr>
+          <p:cNvPr id="8" name="TextBox 7"/>
+          <p:cNvSpPr txBox="1"/>
+          <p:nvPr/>
+        </p:nvSpPr>
+        <p:spPr>
+          <a:xfrm>
+            <a:off x="566928" y="2194560"/>
+            <a:ext cx="5303520" cy="777240"/>
+          </a:xfrm>
+          <a:prstGeom prst="rect">
+            <a:avLst/>
+          </a:prstGeom>
+          <a:noFill/>
+        </p:spPr>
+        <p:txBody>
+          <a:bodyPr wrap="square">
+            <a:spAutoFit/>
+          </a:bodyPr>
+          <a:lstStyle/>
+          <a:p>
+            <a:pPr algn="l"/>
+            <a:r>
+              <a:rPr sz="1600" b="0" i="0">
+                <a:solidFill>
+                  <a:srgbClr val="222233"/>
+                </a:solidFill>
+              </a:rPr>
+              <a:t>Used OpenWeatherMap REST API instead</a:t>
+            </a:r>
+          </a:p>
+        </p:txBody>
+      </p:sp>
+      <p:sp>
+        <p:nvSpPr>
+          <p:cNvPr id="9" name="Rectangle 8"/>
           <p:cNvSpPr/>
           <p:nvPr/>
         </p:nvSpPr>
         <p:spPr>
           <a:xfrm>
-            <a:off x="320040" y="1572768"/>
-            <a:ext cx="5029200" cy="3017520"/>
+            <a:off x="6382512" y="1170432"/>
+            <a:ext cx="5669280" cy="1920240"/>
+          </a:xfrm>
+          <a:prstGeom prst="rect">
+            <a:avLst/>
+          </a:prstGeom>
+          <a:solidFill>
+            <a:srgbClr val="F4F6F9"/>
+          </a:solidFill>
+          <a:ln>
+            <a:noFill/>
+          </a:ln>
+        </p:spPr>
+        <p:style>
+          <a:lnRef idx="1">
+            <a:schemeClr val="accent1"/>
+          </a:lnRef>
+          <a:fillRef idx="3">
+            <a:schemeClr val="accent1"/>
+          </a:fillRef>
+          <a:effectRef idx="2">
+            <a:schemeClr val="accent1"/>
+          </a:effectRef>
+          <a:fontRef idx="minor">
+            <a:schemeClr val="lt1"/>
+          </a:fontRef>
+        </p:style>
+        <p:txBody>
+          <a:bodyPr rtlCol="0" anchor="ctr"/>
+          <a:lstStyle/>
+          <a:p>
+            <a:pPr algn="ctr"/>
+            <a:endParaRPr/>
+          </a:p>
+        </p:txBody>
+      </p:sp>
+      <p:sp>
+        <p:nvSpPr>
+          <p:cNvPr id="10" name="Rectangle 9"/>
+          <p:cNvSpPr/>
+          <p:nvPr/>
+        </p:nvSpPr>
+        <p:spPr>
+          <a:xfrm>
+            <a:off x="6382512" y="1170432"/>
+            <a:ext cx="182880" cy="1920240"/>
           </a:xfrm>
           <a:prstGeom prst="rect">
             <a:avLst/>
@@ -4397,14 +4596,14 @@
       </p:sp>
       <p:sp>
         <p:nvSpPr>
-          <p:cNvPr id="6" name="TextBox 5"/>
+          <p:cNvPr id="11" name="TextBox 10"/>
           <p:cNvSpPr txBox="1"/>
           <p:nvPr/>
         </p:nvSpPr>
         <p:spPr>
           <a:xfrm>
-            <a:off x="320040" y="1664208"/>
-            <a:ext cx="5029200" cy="1280160"/>
+            <a:off x="6675120" y="1280160"/>
+            <a:ext cx="5303520" cy="384048"/>
           </a:xfrm>
           <a:prstGeom prst="rect">
             <a:avLst/>
@@ -4417,28 +4616,28 @@
           </a:bodyPr>
           <a:lstStyle/>
           <a:p>
-            <a:pPr algn="ctr"/>
-            <a:r>
-              <a:rPr sz="5200" b="1" i="0">
-                <a:solidFill>
-                  <a:srgbClr val="FFFFFF"/>
-                </a:solidFill>
-              </a:rPr>
-              <a:t>10,022,333</a:t>
-            </a:r>
-          </a:p>
-        </p:txBody>
-      </p:sp>
-      <p:sp>
-        <p:nvSpPr>
-          <p:cNvPr id="7" name="TextBox 6"/>
+            <a:pPr algn="l"/>
+            <a:r>
+              <a:rPr sz="1700" b="1" i="0">
+                <a:solidFill>
+                  <a:srgbClr val="1C3557"/>
+                </a:solidFill>
+              </a:rPr>
+              <a:t>Sidebar navigation</a:t>
+            </a:r>
+          </a:p>
+        </p:txBody>
+      </p:sp>
+      <p:sp>
+        <p:nvSpPr>
+          <p:cNvPr id="12" name="TextBox 11"/>
           <p:cNvSpPr txBox="1"/>
           <p:nvPr/>
         </p:nvSpPr>
         <p:spPr>
           <a:xfrm>
-            <a:off x="320040" y="2834640"/>
-            <a:ext cx="5029200" cy="457200"/>
+            <a:off x="6675120" y="1700784"/>
+            <a:ext cx="5303520" cy="457200"/>
           </a:xfrm>
           <a:prstGeom prst="rect">
             <a:avLst/>
@@ -4451,28 +4650,28 @@
           </a:bodyPr>
           <a:lstStyle/>
           <a:p>
-            <a:pPr algn="ctr"/>
-            <a:r>
-              <a:rPr sz="1800" b="0" i="0">
-                <a:solidFill>
-                  <a:srgbClr val="CCE5FF"/>
-                </a:solidFill>
-              </a:rPr>
-              <a:t>Total Tokens Processed</a:t>
-            </a:r>
-          </a:p>
-        </p:txBody>
-      </p:sp>
-      <p:sp>
-        <p:nvSpPr>
-          <p:cNvPr id="8" name="TextBox 7"/>
+            <a:pPr algn="l"/>
+            <a:r>
+              <a:rPr sz="1600" b="0" i="1">
+                <a:solidFill>
+                  <a:srgbClr val="993322"/>
+                </a:solidFill>
+              </a:rPr>
+              <a:t>No native drawer equivalent on Android</a:t>
+            </a:r>
+          </a:p>
+        </p:txBody>
+      </p:sp>
+      <p:sp>
+        <p:nvSpPr>
+          <p:cNvPr id="13" name="TextBox 12"/>
           <p:cNvSpPr txBox="1"/>
           <p:nvPr/>
         </p:nvSpPr>
         <p:spPr>
           <a:xfrm>
-            <a:off x="320040" y="3273552"/>
-            <a:ext cx="5029200" cy="329184"/>
+            <a:off x="6675120" y="2194560"/>
+            <a:ext cx="5303520" cy="777240"/>
           </a:xfrm>
           <a:prstGeom prst="rect">
             <a:avLst/>
@@ -4485,34 +4684,34 @@
           </a:bodyPr>
           <a:lstStyle/>
           <a:p>
-            <a:pPr algn="ctr"/>
-            <a:r>
-              <a:rPr sz="1400" b="0" i="1">
-                <a:solidFill>
-                  <a:srgbClr val="AACCFF"/>
-                </a:solidFill>
-              </a:rPr>
-              <a:t>(including cache)</a:t>
-            </a:r>
-          </a:p>
-        </p:txBody>
-      </p:sp>
-      <p:sp>
-        <p:nvSpPr>
-          <p:cNvPr id="9" name="Rectangle 8"/>
+            <a:pPr algn="l"/>
+            <a:r>
+              <a:rPr sz="1600" b="0" i="0">
+                <a:solidFill>
+                  <a:srgbClr val="222233"/>
+                </a:solidFill>
+              </a:rPr>
+              <a:t>Left sidebar --&gt; search dialog   /   Right --&gt; BottomSheet</a:t>
+            </a:r>
+          </a:p>
+        </p:txBody>
+      </p:sp>
+      <p:sp>
+        <p:nvSpPr>
+          <p:cNvPr id="14" name="Rectangle 13"/>
           <p:cNvSpPr/>
           <p:nvPr/>
         </p:nvSpPr>
         <p:spPr>
           <a:xfrm>
-            <a:off x="5577840" y="1572768"/>
-            <a:ext cx="3246120" cy="1298448"/>
+            <a:off x="274320" y="3200400"/>
+            <a:ext cx="5669280" cy="1920240"/>
           </a:xfrm>
           <a:prstGeom prst="rect">
             <a:avLst/>
           </a:prstGeom>
           <a:solidFill>
-            <a:srgbClr val="1A6B3C"/>
+            <a:srgbClr val="F4F6F9"/>
           </a:solidFill>
           <a:ln>
             <a:noFill/>
@@ -4543,88 +4742,20 @@
       </p:sp>
       <p:sp>
         <p:nvSpPr>
-          <p:cNvPr id="10" name="TextBox 9"/>
-          <p:cNvSpPr txBox="1"/>
-          <p:nvPr/>
-        </p:nvSpPr>
-        <p:spPr>
-          <a:xfrm>
-            <a:off x="5577840" y="1682496"/>
-            <a:ext cx="3246120" cy="685800"/>
-          </a:xfrm>
-          <a:prstGeom prst="rect">
-            <a:avLst/>
-          </a:prstGeom>
-          <a:noFill/>
-        </p:spPr>
-        <p:txBody>
-          <a:bodyPr wrap="square">
-            <a:spAutoFit/>
-          </a:bodyPr>
-          <a:lstStyle/>
-          <a:p>
-            <a:pPr algn="ctr"/>
-            <a:r>
-              <a:rPr sz="3000" b="1" i="0">
-                <a:solidFill>
-                  <a:srgbClr val="A8FFC8"/>
-                </a:solidFill>
-              </a:rPr>
-              <a:t>9,094,592</a:t>
-            </a:r>
-          </a:p>
-        </p:txBody>
-      </p:sp>
-      <p:sp>
-        <p:nvSpPr>
-          <p:cNvPr id="11" name="TextBox 10"/>
-          <p:cNvSpPr txBox="1"/>
-          <p:nvPr/>
-        </p:nvSpPr>
-        <p:spPr>
-          <a:xfrm>
-            <a:off x="5577840" y="2377440"/>
-            <a:ext cx="3246120" cy="420624"/>
-          </a:xfrm>
-          <a:prstGeom prst="rect">
-            <a:avLst/>
-          </a:prstGeom>
-          <a:noFill/>
-        </p:spPr>
-        <p:txBody>
-          <a:bodyPr wrap="square">
-            <a:spAutoFit/>
-          </a:bodyPr>
-          <a:lstStyle/>
-          <a:p>
-            <a:pPr algn="ctr"/>
-            <a:r>
-              <a:rPr sz="1400" b="0" i="0">
-                <a:solidFill>
-                  <a:srgbClr val="FFFFFF"/>
-                </a:solidFill>
-              </a:rPr>
-              <a:t>Cache Read Tokens</a:t>
-            </a:r>
-          </a:p>
-        </p:txBody>
-      </p:sp>
-      <p:sp>
-        <p:nvSpPr>
-          <p:cNvPr id="12" name="Rectangle 11"/>
+          <p:cNvPr id="15" name="Rectangle 14"/>
           <p:cNvSpPr/>
           <p:nvPr/>
         </p:nvSpPr>
         <p:spPr>
           <a:xfrm>
-            <a:off x="9025128" y="1572768"/>
-            <a:ext cx="3246120" cy="1298448"/>
+            <a:off x="274320" y="3200400"/>
+            <a:ext cx="182880" cy="1920240"/>
           </a:xfrm>
           <a:prstGeom prst="rect">
             <a:avLst/>
           </a:prstGeom>
           <a:solidFill>
-            <a:srgbClr val="5B2D8E"/>
+            <a:srgbClr val="8E44AD"/>
           </a:solidFill>
           <a:ln>
             <a:noFill/>
@@ -4655,14 +4786,14 @@
       </p:sp>
       <p:sp>
         <p:nvSpPr>
-          <p:cNvPr id="13" name="TextBox 12"/>
+          <p:cNvPr id="16" name="TextBox 15"/>
           <p:cNvSpPr txBox="1"/>
           <p:nvPr/>
         </p:nvSpPr>
         <p:spPr>
           <a:xfrm>
-            <a:off x="9025128" y="1682496"/>
-            <a:ext cx="3246120" cy="685800"/>
+            <a:off x="566928" y="3310128"/>
+            <a:ext cx="5303520" cy="384048"/>
           </a:xfrm>
           <a:prstGeom prst="rect">
             <a:avLst/>
@@ -4675,28 +4806,28 @@
           </a:bodyPr>
           <a:lstStyle/>
           <a:p>
-            <a:pPr algn="ctr"/>
-            <a:r>
-              <a:rPr sz="3000" b="1" i="0">
-                <a:solidFill>
-                  <a:srgbClr val="DDBBFF"/>
-                </a:solidFill>
-              </a:rPr>
-              <a:t>584,219</a:t>
-            </a:r>
-          </a:p>
-        </p:txBody>
-      </p:sp>
-      <p:sp>
-        <p:nvSpPr>
-          <p:cNvPr id="14" name="TextBox 13"/>
+            <a:pPr algn="l"/>
+            <a:r>
+              <a:rPr sz="1700" b="1" i="0">
+                <a:solidFill>
+                  <a:srgbClr val="1C3557"/>
+                </a:solidFill>
+              </a:rPr>
+              <a:t>Missing Version Catalog</a:t>
+            </a:r>
+          </a:p>
+        </p:txBody>
+      </p:sp>
+      <p:sp>
+        <p:nvSpPr>
+          <p:cNvPr id="17" name="TextBox 16"/>
           <p:cNvSpPr txBox="1"/>
           <p:nvPr/>
         </p:nvSpPr>
         <p:spPr>
           <a:xfrm>
-            <a:off x="9025128" y="2377440"/>
-            <a:ext cx="3246120" cy="420624"/>
+            <a:off x="566928" y="3730752"/>
+            <a:ext cx="5303520" cy="457200"/>
           </a:xfrm>
           <a:prstGeom prst="rect">
             <a:avLst/>
@@ -4709,34 +4840,68 @@
           </a:bodyPr>
           <a:lstStyle/>
           <a:p>
-            <a:pPr algn="ctr"/>
-            <a:r>
-              <a:rPr sz="1400" b="0" i="0">
-                <a:solidFill>
-                  <a:srgbClr val="FFFFFF"/>
-                </a:solidFill>
-              </a:rPr>
-              <a:t>Cache Write Tokens</a:t>
-            </a:r>
-          </a:p>
-        </p:txBody>
-      </p:sp>
-      <p:sp>
-        <p:nvSpPr>
-          <p:cNvPr id="15" name="Rectangle 14"/>
+            <a:pPr algn="l"/>
+            <a:r>
+              <a:rPr sz="1600" b="0" i="1">
+                <a:solidFill>
+                  <a:srgbClr val="993322"/>
+                </a:solidFill>
+              </a:rPr>
+              <a:t>gradle/ was gitignored -- build broken</a:t>
+            </a:r>
+          </a:p>
+        </p:txBody>
+      </p:sp>
+      <p:sp>
+        <p:nvSpPr>
+          <p:cNvPr id="18" name="TextBox 17"/>
+          <p:cNvSpPr txBox="1"/>
+          <p:nvPr/>
+        </p:nvSpPr>
+        <p:spPr>
+          <a:xfrm>
+            <a:off x="566928" y="4224528"/>
+            <a:ext cx="5303520" cy="777240"/>
+          </a:xfrm>
+          <a:prstGeom prst="rect">
+            <a:avLst/>
+          </a:prstGeom>
+          <a:noFill/>
+        </p:spPr>
+        <p:txBody>
+          <a:bodyPr wrap="square">
+            <a:spAutoFit/>
+          </a:bodyPr>
+          <a:lstStyle/>
+          <a:p>
+            <a:pPr algn="l"/>
+            <a:r>
+              <a:rPr sz="1600" b="0" i="0">
+                <a:solidFill>
+                  <a:srgbClr val="222233"/>
+                </a:solidFill>
+              </a:rPr>
+              <a:t>Fixed .gitignore, recreated libs.versions.toml</a:t>
+            </a:r>
+          </a:p>
+        </p:txBody>
+      </p:sp>
+      <p:sp>
+        <p:nvSpPr>
+          <p:cNvPr id="19" name="Rectangle 18"/>
           <p:cNvSpPr/>
           <p:nvPr/>
         </p:nvSpPr>
         <p:spPr>
           <a:xfrm>
-            <a:off x="5577840" y="3017520"/>
-            <a:ext cx="3246120" cy="1298448"/>
+            <a:off x="6382512" y="3200400"/>
+            <a:ext cx="5669280" cy="1920240"/>
           </a:xfrm>
           <a:prstGeom prst="rect">
             <a:avLst/>
           </a:prstGeom>
           <a:solidFill>
-            <a:srgbClr val="B84600"/>
+            <a:srgbClr val="F4F6F9"/>
           </a:solidFill>
           <a:ln>
             <a:noFill/>
@@ -4767,89 +4932,20 @@
       </p:sp>
       <p:sp>
         <p:nvSpPr>
-          <p:cNvPr id="16" name="TextBox 15"/>
-          <p:cNvSpPr txBox="1"/>
-          <p:nvPr/>
-        </p:nvSpPr>
-        <p:spPr>
-          <a:xfrm>
-            <a:off x="5577840" y="3127248"/>
-            <a:ext cx="3246120" cy="685800"/>
-          </a:xfrm>
-          <a:prstGeom prst="rect">
-            <a:avLst/>
-          </a:prstGeom>
-          <a:noFill/>
-        </p:spPr>
-        <p:txBody>
-          <a:bodyPr wrap="square">
-            <a:spAutoFit/>
-          </a:bodyPr>
-          <a:lstStyle/>
-          <a:p>
-            <a:pPr algn="ctr"/>
-            <a:r>
-              <a:rPr sz="3000" b="1" i="0">
-                <a:solidFill>
-                  <a:srgbClr val="FFCC88"/>
-                </a:solidFill>
-              </a:rPr>
-              <a:t>343,087</a:t>
-            </a:r>
-          </a:p>
-        </p:txBody>
-      </p:sp>
-      <p:sp>
-        <p:nvSpPr>
-          <p:cNvPr id="17" name="TextBox 16"/>
-          <p:cNvSpPr txBox="1"/>
-          <p:nvPr/>
-        </p:nvSpPr>
-        <p:spPr>
-          <a:xfrm>
-            <a:off x="5577840" y="3822192"/>
-            <a:ext cx="3246120" cy="420624"/>
-          </a:xfrm>
-          <a:prstGeom prst="rect">
-            <a:avLst/>
-          </a:prstGeom>
-          <a:noFill/>
-        </p:spPr>
-        <p:txBody>
-          <a:bodyPr wrap="square">
-            <a:spAutoFit/>
-          </a:bodyPr>
-          <a:lstStyle/>
-          <a:p>
-            <a:pPr algn="ctr"/>
-            <a:r>
-              <a:rPr sz="1400" b="0" i="0">
-                <a:solidFill>
-                  <a:srgbClr val="FFFFFF"/>
-                </a:solidFill>
-              </a:rPr>
-              <a:t>Output Tokens
-(Claude responses)</a:t>
-            </a:r>
-          </a:p>
-        </p:txBody>
-      </p:sp>
-      <p:sp>
-        <p:nvSpPr>
-          <p:cNvPr id="18" name="Rectangle 17"/>
+          <p:cNvPr id="20" name="Rectangle 19"/>
           <p:cNvSpPr/>
           <p:nvPr/>
         </p:nvSpPr>
         <p:spPr>
           <a:xfrm>
-            <a:off x="9025128" y="3017520"/>
-            <a:ext cx="3246120" cy="1298448"/>
+            <a:off x="6382512" y="3200400"/>
+            <a:ext cx="182880" cy="1920240"/>
           </a:xfrm>
           <a:prstGeom prst="rect">
             <a:avLst/>
           </a:prstGeom>
           <a:solidFill>
-            <a:srgbClr val="1C3557"/>
+            <a:srgbClr val="3DDC84"/>
           </a:solidFill>
           <a:ln>
             <a:noFill/>
@@ -4880,14 +4976,14 @@
       </p:sp>
       <p:sp>
         <p:nvSpPr>
-          <p:cNvPr id="19" name="TextBox 18"/>
+          <p:cNvPr id="21" name="TextBox 20"/>
           <p:cNvSpPr txBox="1"/>
           <p:nvPr/>
         </p:nvSpPr>
         <p:spPr>
           <a:xfrm>
-            <a:off x="9025128" y="3127248"/>
-            <a:ext cx="3246120" cy="685800"/>
+            <a:off x="6675120" y="3310128"/>
+            <a:ext cx="5303520" cy="384048"/>
           </a:xfrm>
           <a:prstGeom prst="rect">
             <a:avLst/>
@@ -4900,28 +4996,28 @@
           </a:bodyPr>
           <a:lstStyle/>
           <a:p>
-            <a:pPr algn="ctr"/>
-            <a:r>
-              <a:rPr sz="3000" b="1" i="0">
-                <a:solidFill>
-                  <a:srgbClr val="AACCFF"/>
-                </a:solidFill>
-              </a:rPr>
-              <a:t>435</a:t>
-            </a:r>
-          </a:p>
-        </p:txBody>
-      </p:sp>
-      <p:sp>
-        <p:nvSpPr>
-          <p:cNvPr id="20" name="TextBox 19"/>
+            <a:pPr algn="l"/>
+            <a:r>
+              <a:rPr sz="1700" b="1" i="0">
+                <a:solidFill>
+                  <a:srgbClr val="1C3557"/>
+                </a:solidFill>
+              </a:rPr>
+              <a:t>State management</a:t>
+            </a:r>
+          </a:p>
+        </p:txBody>
+      </p:sp>
+      <p:sp>
+        <p:nvSpPr>
+          <p:cNvPr id="22" name="TextBox 21"/>
           <p:cNvSpPr txBox="1"/>
           <p:nvPr/>
         </p:nvSpPr>
         <p:spPr>
           <a:xfrm>
-            <a:off x="9025128" y="3822192"/>
-            <a:ext cx="3246120" cy="420624"/>
+            <a:off x="6675120" y="3730752"/>
+            <a:ext cx="5303520" cy="457200"/>
           </a:xfrm>
           <a:prstGeom prst="rect">
             <a:avLst/>
@@ -4934,14 +5030,48 @@
           </a:bodyPr>
           <a:lstStyle/>
           <a:p>
-            <a:pPr algn="ctr"/>
-            <a:r>
-              <a:rPr sz="1400" b="0" i="0">
-                <a:solidFill>
-                  <a:srgbClr val="FFFFFF"/>
-                </a:solidFill>
-              </a:rPr>
-              <a:t>Fresh Input Tokens</a:t>
+            <a:pPr algn="l"/>
+            <a:r>
+              <a:rPr sz="1600" b="0" i="1">
+                <a:solidFill>
+                  <a:srgbClr val="993322"/>
+                </a:solidFill>
+              </a:rPr>
+              <a:t>No @EnvironmentObject in Compose</a:t>
+            </a:r>
+          </a:p>
+        </p:txBody>
+      </p:sp>
+      <p:sp>
+        <p:nvSpPr>
+          <p:cNvPr id="23" name="TextBox 22"/>
+          <p:cNvSpPr txBox="1"/>
+          <p:nvPr/>
+        </p:nvSpPr>
+        <p:spPr>
+          <a:xfrm>
+            <a:off x="6675120" y="4224528"/>
+            <a:ext cx="5303520" cy="777240"/>
+          </a:xfrm>
+          <a:prstGeom prst="rect">
+            <a:avLst/>
+          </a:prstGeom>
+          <a:noFill/>
+        </p:spPr>
+        <p:txBody>
+          <a:bodyPr wrap="square">
+            <a:spAutoFit/>
+          </a:bodyPr>
+          <a:lstStyle/>
+          <a:p>
+            <a:pPr algn="l"/>
+            <a:r>
+              <a:rPr sz="1600" b="0" i="0">
+                <a:solidFill>
+                  <a:srgbClr val="222233"/>
+                </a:solidFill>
+              </a:rPr>
+              <a:t>ViewModel + StateFlow + collectAsState()</a:t>
             </a:r>
           </a:p>
         </p:txBody>
@@ -5052,7 +5182,7 @@
                   <a:srgbClr val="FFFFFF"/>
                 </a:solidFill>
               </a:rPr>
-              <a:t>Key Challenges</a:t>
+              <a:t>Results &amp; Conclusion</a:t>
             </a:r>
           </a:p>
         </p:txBody>
@@ -5065,8 +5195,584 @@
         </p:nvSpPr>
         <p:spPr>
           <a:xfrm>
-            <a:off x="274320" y="1170432"/>
-            <a:ext cx="5669280" cy="1920240"/>
+            <a:off x="347472" y="1170432"/>
+            <a:ext cx="2103120" cy="1554480"/>
+          </a:xfrm>
+          <a:prstGeom prst="rect">
+            <a:avLst/>
+          </a:prstGeom>
+          <a:solidFill>
+            <a:srgbClr val="1C3557"/>
+          </a:solidFill>
+          <a:ln>
+            <a:noFill/>
+          </a:ln>
+        </p:spPr>
+        <p:style>
+          <a:lnRef idx="1">
+            <a:schemeClr val="accent1"/>
+          </a:lnRef>
+          <a:fillRef idx="3">
+            <a:schemeClr val="accent1"/>
+          </a:fillRef>
+          <a:effectRef idx="2">
+            <a:schemeClr val="accent1"/>
+          </a:effectRef>
+          <a:fontRef idx="minor">
+            <a:schemeClr val="lt1"/>
+          </a:fontRef>
+        </p:style>
+        <p:txBody>
+          <a:bodyPr rtlCol="0" anchor="ctr"/>
+          <a:lstStyle/>
+          <a:p>
+            <a:pPr algn="ctr"/>
+            <a:endParaRPr/>
+          </a:p>
+        </p:txBody>
+      </p:sp>
+      <p:sp>
+        <p:nvSpPr>
+          <p:cNvPr id="5" name="TextBox 4"/>
+          <p:cNvSpPr txBox="1"/>
+          <p:nvPr/>
+        </p:nvSpPr>
+        <p:spPr>
+          <a:xfrm>
+            <a:off x="347472" y="1216152"/>
+            <a:ext cx="2103120" cy="804672"/>
+          </a:xfrm>
+          <a:prstGeom prst="rect">
+            <a:avLst/>
+          </a:prstGeom>
+          <a:noFill/>
+        </p:spPr>
+        <p:txBody>
+          <a:bodyPr wrap="square">
+            <a:spAutoFit/>
+          </a:bodyPr>
+          <a:lstStyle/>
+          <a:p>
+            <a:pPr algn="ctr"/>
+            <a:r>
+              <a:rPr sz="4000" b="1" i="0">
+                <a:solidFill>
+                  <a:srgbClr val="4A90E2"/>
+                </a:solidFill>
+              </a:rPr>
+              <a:t>10+</a:t>
+            </a:r>
+          </a:p>
+        </p:txBody>
+      </p:sp>
+      <p:sp>
+        <p:nvSpPr>
+          <p:cNvPr id="6" name="TextBox 5"/>
+          <p:cNvSpPr txBox="1"/>
+          <p:nvPr/>
+        </p:nvSpPr>
+        <p:spPr>
+          <a:xfrm>
+            <a:off x="347472" y="1993392"/>
+            <a:ext cx="2103120" cy="658368"/>
+          </a:xfrm>
+          <a:prstGeom prst="rect">
+            <a:avLst/>
+          </a:prstGeom>
+          <a:noFill/>
+        </p:spPr>
+        <p:txBody>
+          <a:bodyPr wrap="square">
+            <a:spAutoFit/>
+          </a:bodyPr>
+          <a:lstStyle/>
+          <a:p>
+            <a:pPr algn="ctr"/>
+            <a:r>
+              <a:rPr sz="1400" b="0" i="0">
+                <a:solidFill>
+                  <a:srgbClr val="FFFFFF"/>
+                </a:solidFill>
+              </a:rPr>
+              <a:t>Swift files
+analysed</a:t>
+            </a:r>
+          </a:p>
+        </p:txBody>
+      </p:sp>
+      <p:sp>
+        <p:nvSpPr>
+          <p:cNvPr id="7" name="Rectangle 6"/>
+          <p:cNvSpPr/>
+          <p:nvPr/>
+        </p:nvSpPr>
+        <p:spPr>
+          <a:xfrm>
+            <a:off x="2615184" y="1170432"/>
+            <a:ext cx="2103120" cy="1554480"/>
+          </a:xfrm>
+          <a:prstGeom prst="rect">
+            <a:avLst/>
+          </a:prstGeom>
+          <a:solidFill>
+            <a:srgbClr val="1C3557"/>
+          </a:solidFill>
+          <a:ln>
+            <a:noFill/>
+          </a:ln>
+        </p:spPr>
+        <p:style>
+          <a:lnRef idx="1">
+            <a:schemeClr val="accent1"/>
+          </a:lnRef>
+          <a:fillRef idx="3">
+            <a:schemeClr val="accent1"/>
+          </a:fillRef>
+          <a:effectRef idx="2">
+            <a:schemeClr val="accent1"/>
+          </a:effectRef>
+          <a:fontRef idx="minor">
+            <a:schemeClr val="lt1"/>
+          </a:fontRef>
+        </p:style>
+        <p:txBody>
+          <a:bodyPr rtlCol="0" anchor="ctr"/>
+          <a:lstStyle/>
+          <a:p>
+            <a:pPr algn="ctr"/>
+            <a:endParaRPr/>
+          </a:p>
+        </p:txBody>
+      </p:sp>
+      <p:sp>
+        <p:nvSpPr>
+          <p:cNvPr id="8" name="TextBox 7"/>
+          <p:cNvSpPr txBox="1"/>
+          <p:nvPr/>
+        </p:nvSpPr>
+        <p:spPr>
+          <a:xfrm>
+            <a:off x="2615184" y="1216152"/>
+            <a:ext cx="2103120" cy="804672"/>
+          </a:xfrm>
+          <a:prstGeom prst="rect">
+            <a:avLst/>
+          </a:prstGeom>
+          <a:noFill/>
+        </p:spPr>
+        <p:txBody>
+          <a:bodyPr wrap="square">
+            <a:spAutoFit/>
+          </a:bodyPr>
+          <a:lstStyle/>
+          <a:p>
+            <a:pPr algn="ctr"/>
+            <a:r>
+              <a:rPr sz="4000" b="1" i="0">
+                <a:solidFill>
+                  <a:srgbClr val="4A90E2"/>
+                </a:solidFill>
+              </a:rPr>
+              <a:t>13</a:t>
+            </a:r>
+          </a:p>
+        </p:txBody>
+      </p:sp>
+      <p:sp>
+        <p:nvSpPr>
+          <p:cNvPr id="9" name="TextBox 8"/>
+          <p:cNvSpPr txBox="1"/>
+          <p:nvPr/>
+        </p:nvSpPr>
+        <p:spPr>
+          <a:xfrm>
+            <a:off x="2615184" y="1993392"/>
+            <a:ext cx="2103120" cy="658368"/>
+          </a:xfrm>
+          <a:prstGeom prst="rect">
+            <a:avLst/>
+          </a:prstGeom>
+          <a:noFill/>
+        </p:spPr>
+        <p:txBody>
+          <a:bodyPr wrap="square">
+            <a:spAutoFit/>
+          </a:bodyPr>
+          <a:lstStyle/>
+          <a:p>
+            <a:pPr algn="ctr"/>
+            <a:r>
+              <a:rPr sz="1400" b="0" i="0">
+                <a:solidFill>
+                  <a:srgbClr val="FFFFFF"/>
+                </a:solidFill>
+              </a:rPr>
+              <a:t>Kotlin files
+created</a:t>
+            </a:r>
+          </a:p>
+        </p:txBody>
+      </p:sp>
+      <p:sp>
+        <p:nvSpPr>
+          <p:cNvPr id="10" name="Rectangle 9"/>
+          <p:cNvSpPr/>
+          <p:nvPr/>
+        </p:nvSpPr>
+        <p:spPr>
+          <a:xfrm>
+            <a:off x="4882896" y="1170432"/>
+            <a:ext cx="2103120" cy="1554480"/>
+          </a:xfrm>
+          <a:prstGeom prst="rect">
+            <a:avLst/>
+          </a:prstGeom>
+          <a:solidFill>
+            <a:srgbClr val="1C3557"/>
+          </a:solidFill>
+          <a:ln>
+            <a:noFill/>
+          </a:ln>
+        </p:spPr>
+        <p:style>
+          <a:lnRef idx="1">
+            <a:schemeClr val="accent1"/>
+          </a:lnRef>
+          <a:fillRef idx="3">
+            <a:schemeClr val="accent1"/>
+          </a:fillRef>
+          <a:effectRef idx="2">
+            <a:schemeClr val="accent1"/>
+          </a:effectRef>
+          <a:fontRef idx="minor">
+            <a:schemeClr val="lt1"/>
+          </a:fontRef>
+        </p:style>
+        <p:txBody>
+          <a:bodyPr rtlCol="0" anchor="ctr"/>
+          <a:lstStyle/>
+          <a:p>
+            <a:pPr algn="ctr"/>
+            <a:endParaRPr/>
+          </a:p>
+        </p:txBody>
+      </p:sp>
+      <p:sp>
+        <p:nvSpPr>
+          <p:cNvPr id="11" name="TextBox 10"/>
+          <p:cNvSpPr txBox="1"/>
+          <p:nvPr/>
+        </p:nvSpPr>
+        <p:spPr>
+          <a:xfrm>
+            <a:off x="4882896" y="1216152"/>
+            <a:ext cx="2103120" cy="804672"/>
+          </a:xfrm>
+          <a:prstGeom prst="rect">
+            <a:avLst/>
+          </a:prstGeom>
+          <a:noFill/>
+        </p:spPr>
+        <p:txBody>
+          <a:bodyPr wrap="square">
+            <a:spAutoFit/>
+          </a:bodyPr>
+          <a:lstStyle/>
+          <a:p>
+            <a:pPr algn="ctr"/>
+            <a:r>
+              <a:rPr sz="4000" b="1" i="0">
+                <a:solidFill>
+                  <a:srgbClr val="4A90E2"/>
+                </a:solidFill>
+              </a:rPr>
+              <a:t>~95%</a:t>
+            </a:r>
+          </a:p>
+        </p:txBody>
+      </p:sp>
+      <p:sp>
+        <p:nvSpPr>
+          <p:cNvPr id="12" name="TextBox 11"/>
+          <p:cNvSpPr txBox="1"/>
+          <p:nvPr/>
+        </p:nvSpPr>
+        <p:spPr>
+          <a:xfrm>
+            <a:off x="4882896" y="1993392"/>
+            <a:ext cx="2103120" cy="658368"/>
+          </a:xfrm>
+          <a:prstGeom prst="rect">
+            <a:avLst/>
+          </a:prstGeom>
+          <a:noFill/>
+        </p:spPr>
+        <p:txBody>
+          <a:bodyPr wrap="square">
+            <a:spAutoFit/>
+          </a:bodyPr>
+          <a:lstStyle/>
+          <a:p>
+            <a:pPr algn="ctr"/>
+            <a:r>
+              <a:rPr sz="1400" b="0" i="0">
+                <a:solidFill>
+                  <a:srgbClr val="FFFFFF"/>
+                </a:solidFill>
+              </a:rPr>
+              <a:t>Feature parity</a:t>
+            </a:r>
+          </a:p>
+        </p:txBody>
+      </p:sp>
+      <p:sp>
+        <p:nvSpPr>
+          <p:cNvPr id="13" name="Rectangle 12"/>
+          <p:cNvSpPr/>
+          <p:nvPr/>
+        </p:nvSpPr>
+        <p:spPr>
+          <a:xfrm>
+            <a:off x="7150608" y="1170432"/>
+            <a:ext cx="2103120" cy="1554480"/>
+          </a:xfrm>
+          <a:prstGeom prst="rect">
+            <a:avLst/>
+          </a:prstGeom>
+          <a:solidFill>
+            <a:srgbClr val="1C3557"/>
+          </a:solidFill>
+          <a:ln>
+            <a:noFill/>
+          </a:ln>
+        </p:spPr>
+        <p:style>
+          <a:lnRef idx="1">
+            <a:schemeClr val="accent1"/>
+          </a:lnRef>
+          <a:fillRef idx="3">
+            <a:schemeClr val="accent1"/>
+          </a:fillRef>
+          <a:effectRef idx="2">
+            <a:schemeClr val="accent1"/>
+          </a:effectRef>
+          <a:fontRef idx="minor">
+            <a:schemeClr val="lt1"/>
+          </a:fontRef>
+        </p:style>
+        <p:txBody>
+          <a:bodyPr rtlCol="0" anchor="ctr"/>
+          <a:lstStyle/>
+          <a:p>
+            <a:pPr algn="ctr"/>
+            <a:endParaRPr/>
+          </a:p>
+        </p:txBody>
+      </p:sp>
+      <p:sp>
+        <p:nvSpPr>
+          <p:cNvPr id="14" name="TextBox 13"/>
+          <p:cNvSpPr txBox="1"/>
+          <p:nvPr/>
+        </p:nvSpPr>
+        <p:spPr>
+          <a:xfrm>
+            <a:off x="7150608" y="1216152"/>
+            <a:ext cx="2103120" cy="707886"/>
+          </a:xfrm>
+          <a:prstGeom prst="rect">
+            <a:avLst/>
+          </a:prstGeom>
+          <a:noFill/>
+        </p:spPr>
+        <p:txBody>
+          <a:bodyPr wrap="square">
+            <a:spAutoFit/>
+          </a:bodyPr>
+          <a:lstStyle/>
+          <a:p>
+            <a:pPr algn="ctr"/>
+            <a:r>
+              <a:rPr lang="de-DE" sz="4000" b="1" dirty="0">
+                <a:solidFill>
+                  <a:srgbClr val="4A90E2"/>
+                </a:solidFill>
+              </a:rPr>
+              <a:t>&gt;400k</a:t>
+            </a:r>
+            <a:endParaRPr sz="4000" b="1" i="0" dirty="0">
+              <a:solidFill>
+                <a:srgbClr val="4A90E2"/>
+              </a:solidFill>
+            </a:endParaRPr>
+          </a:p>
+        </p:txBody>
+      </p:sp>
+      <p:sp>
+        <p:nvSpPr>
+          <p:cNvPr id="15" name="TextBox 14"/>
+          <p:cNvSpPr txBox="1"/>
+          <p:nvPr/>
+        </p:nvSpPr>
+        <p:spPr>
+          <a:xfrm>
+            <a:off x="7150608" y="1993392"/>
+            <a:ext cx="2103120" cy="523220"/>
+          </a:xfrm>
+          <a:prstGeom prst="rect">
+            <a:avLst/>
+          </a:prstGeom>
+          <a:noFill/>
+        </p:spPr>
+        <p:txBody>
+          <a:bodyPr wrap="square">
+            <a:spAutoFit/>
+          </a:bodyPr>
+          <a:lstStyle/>
+          <a:p>
+            <a:pPr algn="ctr"/>
+            <a:r>
+              <a:rPr lang="de-DE" sz="1400" b="0" i="0" dirty="0" err="1">
+                <a:solidFill>
+                  <a:srgbClr val="FFFFFF"/>
+                </a:solidFill>
+              </a:rPr>
+              <a:t>tokens</a:t>
+            </a:r>
+            <a:r>
+              <a:rPr sz="1400" b="0" i="0" dirty="0">
+                <a:solidFill>
+                  <a:srgbClr val="FFFFFF"/>
+                </a:solidFill>
+              </a:rPr>
+              <a:t>
+used</a:t>
+            </a:r>
+          </a:p>
+        </p:txBody>
+      </p:sp>
+      <p:sp>
+        <p:nvSpPr>
+          <p:cNvPr id="16" name="Rectangle 15"/>
+          <p:cNvSpPr/>
+          <p:nvPr/>
+        </p:nvSpPr>
+        <p:spPr>
+          <a:xfrm>
+            <a:off x="9418320" y="1170432"/>
+            <a:ext cx="2103120" cy="1554480"/>
+          </a:xfrm>
+          <a:prstGeom prst="rect">
+            <a:avLst/>
+          </a:prstGeom>
+          <a:solidFill>
+            <a:srgbClr val="1C3557"/>
+          </a:solidFill>
+          <a:ln>
+            <a:noFill/>
+          </a:ln>
+        </p:spPr>
+        <p:style>
+          <a:lnRef idx="1">
+            <a:schemeClr val="accent1"/>
+          </a:lnRef>
+          <a:fillRef idx="3">
+            <a:schemeClr val="accent1"/>
+          </a:fillRef>
+          <a:effectRef idx="2">
+            <a:schemeClr val="accent1"/>
+          </a:effectRef>
+          <a:fontRef idx="minor">
+            <a:schemeClr val="lt1"/>
+          </a:fontRef>
+        </p:style>
+        <p:txBody>
+          <a:bodyPr rtlCol="0" anchor="ctr"/>
+          <a:lstStyle/>
+          <a:p>
+            <a:pPr algn="ctr"/>
+            <a:endParaRPr/>
+          </a:p>
+        </p:txBody>
+      </p:sp>
+      <p:sp>
+        <p:nvSpPr>
+          <p:cNvPr id="17" name="TextBox 16"/>
+          <p:cNvSpPr txBox="1"/>
+          <p:nvPr/>
+        </p:nvSpPr>
+        <p:spPr>
+          <a:xfrm>
+            <a:off x="9418320" y="1216152"/>
+            <a:ext cx="2103120" cy="804672"/>
+          </a:xfrm>
+          <a:prstGeom prst="rect">
+            <a:avLst/>
+          </a:prstGeom>
+          <a:noFill/>
+        </p:spPr>
+        <p:txBody>
+          <a:bodyPr wrap="square">
+            <a:spAutoFit/>
+          </a:bodyPr>
+          <a:lstStyle/>
+          <a:p>
+            <a:pPr algn="ctr"/>
+            <a:r>
+              <a:rPr sz="4000" b="1" i="0" dirty="0">
+                <a:solidFill>
+                  <a:srgbClr val="4A90E2"/>
+                </a:solidFill>
+              </a:rPr>
+              <a:t>&lt;1 week</a:t>
+            </a:r>
+          </a:p>
+        </p:txBody>
+      </p:sp>
+      <p:sp>
+        <p:nvSpPr>
+          <p:cNvPr id="18" name="TextBox 17"/>
+          <p:cNvSpPr txBox="1"/>
+          <p:nvPr/>
+        </p:nvSpPr>
+        <p:spPr>
+          <a:xfrm>
+            <a:off x="9418320" y="1993392"/>
+            <a:ext cx="2103120" cy="658368"/>
+          </a:xfrm>
+          <a:prstGeom prst="rect">
+            <a:avLst/>
+          </a:prstGeom>
+          <a:noFill/>
+        </p:spPr>
+        <p:txBody>
+          <a:bodyPr wrap="square">
+            <a:spAutoFit/>
+          </a:bodyPr>
+          <a:lstStyle/>
+          <a:p>
+            <a:pPr algn="ctr"/>
+            <a:r>
+              <a:rPr sz="1400" b="0" i="0">
+                <a:solidFill>
+                  <a:srgbClr val="FFFFFF"/>
+                </a:solidFill>
+              </a:rPr>
+              <a:t>Migration time</a:t>
+            </a:r>
+          </a:p>
+        </p:txBody>
+      </p:sp>
+      <p:sp>
+        <p:nvSpPr>
+          <p:cNvPr id="19" name="Rectangle 18"/>
+          <p:cNvSpPr/>
+          <p:nvPr/>
+        </p:nvSpPr>
+        <p:spPr>
+          <a:xfrm>
+            <a:off x="320040" y="2907792"/>
+            <a:ext cx="5669280" cy="3703320"/>
           </a:xfrm>
           <a:prstGeom prst="rect">
             <a:avLst/>
@@ -5103,20 +5809,20 @@
       </p:sp>
       <p:sp>
         <p:nvSpPr>
-          <p:cNvPr id="5" name="Rectangle 4"/>
+          <p:cNvPr id="20" name="Rectangle 19"/>
           <p:cNvSpPr/>
           <p:nvPr/>
         </p:nvSpPr>
         <p:spPr>
           <a:xfrm>
-            <a:off x="274320" y="1170432"/>
-            <a:ext cx="182880" cy="1920240"/>
+            <a:off x="320040" y="2907792"/>
+            <a:ext cx="5669280" cy="502920"/>
           </a:xfrm>
           <a:prstGeom prst="rect">
             <a:avLst/>
           </a:prstGeom>
           <a:solidFill>
-            <a:srgbClr val="E86A2C"/>
+            <a:srgbClr val="1C3557"/>
           </a:solidFill>
           <a:ln>
             <a:noFill/>
@@ -5147,14 +5853,14 @@
       </p:sp>
       <p:sp>
         <p:nvSpPr>
-          <p:cNvPr id="6" name="TextBox 5"/>
+          <p:cNvPr id="21" name="TextBox 20"/>
           <p:cNvSpPr txBox="1"/>
           <p:nvPr/>
         </p:nvSpPr>
         <p:spPr>
           <a:xfrm>
-            <a:off x="566928" y="1280160"/>
-            <a:ext cx="5303520" cy="384048"/>
+            <a:off x="320040" y="2935224"/>
+            <a:ext cx="5669280" cy="457200"/>
           </a:xfrm>
           <a:prstGeom prst="rect">
             <a:avLst/>
@@ -5167,28 +5873,28 @@
           </a:bodyPr>
           <a:lstStyle/>
           <a:p>
-            <a:pPr algn="l"/>
-            <a:r>
-              <a:rPr sz="1700" b="1" i="0">
-                <a:solidFill>
-                  <a:srgbClr val="1C3557"/>
-                </a:solidFill>
-              </a:rPr>
-              <a:t>WeatherKit not on Android</a:t>
-            </a:r>
-          </a:p>
-        </p:txBody>
-      </p:sp>
-      <p:sp>
-        <p:nvSpPr>
-          <p:cNvPr id="7" name="TextBox 6"/>
+            <a:pPr algn="ctr"/>
+            <a:r>
+              <a:rPr sz="1900" b="1" i="0">
+                <a:solidFill>
+                  <a:srgbClr val="FFFFFF"/>
+                </a:solidFill>
+              </a:rPr>
+              <a:t>What We Learned</a:t>
+            </a:r>
+          </a:p>
+        </p:txBody>
+      </p:sp>
+      <p:sp>
+        <p:nvSpPr>
+          <p:cNvPr id="22" name="TextBox 21"/>
           <p:cNvSpPr txBox="1"/>
           <p:nvPr/>
         </p:nvSpPr>
         <p:spPr>
           <a:xfrm>
-            <a:off x="566928" y="1700784"/>
-            <a:ext cx="5303520" cy="457200"/>
+            <a:off x="457200" y="3502152"/>
+            <a:ext cx="5394960" cy="2971800"/>
           </a:xfrm>
           <a:prstGeom prst="rect">
             <a:avLst/>
@@ -5201,62 +5907,62 @@
           </a:bodyPr>
           <a:lstStyle/>
           <a:p>
-            <a:pPr algn="l"/>
-            <a:r>
-              <a:rPr sz="1600" b="0" i="1">
-                <a:solidFill>
-                  <a:srgbClr val="993322"/>
-                </a:solidFill>
-              </a:rPr>
-              <a:t>Apple-exclusive API</a:t>
-            </a:r>
-          </a:p>
-        </p:txBody>
-      </p:sp>
-      <p:sp>
-        <p:nvSpPr>
-          <p:cNvPr id="8" name="TextBox 7"/>
-          <p:cNvSpPr txBox="1"/>
-          <p:nvPr/>
-        </p:nvSpPr>
-        <p:spPr>
-          <a:xfrm>
-            <a:off x="566928" y="2194560"/>
-            <a:ext cx="5303520" cy="777240"/>
-          </a:xfrm>
-          <a:prstGeom prst="rect">
-            <a:avLst/>
-          </a:prstGeom>
-          <a:noFill/>
-        </p:spPr>
-        <p:txBody>
-          <a:bodyPr wrap="square">
-            <a:spAutoFit/>
-          </a:bodyPr>
-          <a:lstStyle/>
-          <a:p>
-            <a:pPr algn="l"/>
-            <a:r>
-              <a:rPr sz="1600" b="0" i="0">
+            <a:pPr>
+              <a:spcBef>
+                <a:spcPts val="1800"/>
+              </a:spcBef>
+            </a:pPr>
+            <a:r>
+              <a:rPr sz="2000" dirty="0">
                 <a:solidFill>
                   <a:srgbClr val="222233"/>
                 </a:solidFill>
               </a:rPr>
-              <a:t>Used OpenWeatherMap REST API instead</a:t>
-            </a:r>
-          </a:p>
-        </p:txBody>
-      </p:sp>
-      <p:sp>
-        <p:nvSpPr>
-          <p:cNvPr id="9" name="Rectangle 8"/>
+              <a:t>  AI excels at translating between similar frameworks</a:t>
+            </a:r>
+          </a:p>
+          <a:p>
+            <a:pPr>
+              <a:spcBef>
+                <a:spcPts val="1800"/>
+              </a:spcBef>
+            </a:pPr>
+            <a:r>
+              <a:rPr sz="2000" dirty="0">
+                <a:solidFill>
+                  <a:srgbClr val="222233"/>
+                </a:solidFill>
+              </a:rPr>
+              <a:t>  Iterative prompting beats one-shot generation</a:t>
+            </a:r>
+          </a:p>
+          <a:p>
+            <a:pPr>
+              <a:spcBef>
+                <a:spcPts val="1800"/>
+              </a:spcBef>
+            </a:pPr>
+            <a:r>
+              <a:rPr sz="2000" dirty="0">
+                <a:solidFill>
+                  <a:srgbClr val="222233"/>
+                </a:solidFill>
+              </a:rPr>
+              <a:t>  Human oversight is still essential for config &amp; APIs</a:t>
+            </a:r>
+          </a:p>
+        </p:txBody>
+      </p:sp>
+      <p:sp>
+        <p:nvSpPr>
+          <p:cNvPr id="23" name="Rectangle 22"/>
           <p:cNvSpPr/>
           <p:nvPr/>
         </p:nvSpPr>
         <p:spPr>
           <a:xfrm>
-            <a:off x="6382512" y="1170432"/>
-            <a:ext cx="5669280" cy="1920240"/>
+            <a:off x="6281928" y="2907792"/>
+            <a:ext cx="5669280" cy="3703320"/>
           </a:xfrm>
           <a:prstGeom prst="rect">
             <a:avLst/>
@@ -5293,20 +5999,20 @@
       </p:sp>
       <p:sp>
         <p:nvSpPr>
-          <p:cNvPr id="10" name="Rectangle 9"/>
+          <p:cNvPr id="24" name="Rectangle 23"/>
           <p:cNvSpPr/>
           <p:nvPr/>
         </p:nvSpPr>
         <p:spPr>
           <a:xfrm>
-            <a:off x="6382512" y="1170432"/>
-            <a:ext cx="182880" cy="1920240"/>
+            <a:off x="6281928" y="2907792"/>
+            <a:ext cx="5669280" cy="502920"/>
           </a:xfrm>
           <a:prstGeom prst="rect">
             <a:avLst/>
           </a:prstGeom>
           <a:solidFill>
-            <a:srgbClr val="4A90E2"/>
+            <a:srgbClr val="147A3A"/>
           </a:solidFill>
           <a:ln>
             <a:noFill/>
@@ -5337,14 +6043,14 @@
       </p:sp>
       <p:sp>
         <p:nvSpPr>
-          <p:cNvPr id="11" name="TextBox 10"/>
+          <p:cNvPr id="25" name="TextBox 24"/>
           <p:cNvSpPr txBox="1"/>
           <p:nvPr/>
         </p:nvSpPr>
         <p:spPr>
           <a:xfrm>
-            <a:off x="6675120" y="1280160"/>
-            <a:ext cx="5303520" cy="384048"/>
+            <a:off x="6281928" y="2935224"/>
+            <a:ext cx="5669280" cy="457200"/>
           </a:xfrm>
           <a:prstGeom prst="rect">
             <a:avLst/>
@@ -5357,28 +6063,28 @@
           </a:bodyPr>
           <a:lstStyle/>
           <a:p>
-            <a:pPr algn="l"/>
-            <a:r>
-              <a:rPr sz="1700" b="1" i="0">
-                <a:solidFill>
-                  <a:srgbClr val="1C3557"/>
-                </a:solidFill>
-              </a:rPr>
-              <a:t>Sidebar navigation</a:t>
-            </a:r>
-          </a:p>
-        </p:txBody>
-      </p:sp>
-      <p:sp>
-        <p:nvSpPr>
-          <p:cNvPr id="12" name="TextBox 11"/>
+            <a:pPr algn="ctr"/>
+            <a:r>
+              <a:rPr sz="1900" b="1" i="0">
+                <a:solidFill>
+                  <a:srgbClr val="FFFFFF"/>
+                </a:solidFill>
+              </a:rPr>
+              <a:t>Verdict</a:t>
+            </a:r>
+          </a:p>
+        </p:txBody>
+      </p:sp>
+      <p:sp>
+        <p:nvSpPr>
+          <p:cNvPr id="26" name="TextBox 25"/>
           <p:cNvSpPr txBox="1"/>
           <p:nvPr/>
         </p:nvSpPr>
         <p:spPr>
           <a:xfrm>
-            <a:off x="6675120" y="1700784"/>
-            <a:ext cx="5303520" cy="457200"/>
+            <a:off x="6419088" y="3502152"/>
+            <a:ext cx="5394960" cy="2971800"/>
           </a:xfrm>
           <a:prstGeom prst="rect">
             <a:avLst/>
@@ -5391,428 +6097,48 @@
           </a:bodyPr>
           <a:lstStyle/>
           <a:p>
-            <a:pPr algn="l"/>
-            <a:r>
-              <a:rPr sz="1600" b="0" i="1">
-                <a:solidFill>
-                  <a:srgbClr val="993322"/>
-                </a:solidFill>
-              </a:rPr>
-              <a:t>No native drawer equivalent on Android</a:t>
-            </a:r>
-          </a:p>
-        </p:txBody>
-      </p:sp>
-      <p:sp>
-        <p:nvSpPr>
-          <p:cNvPr id="13" name="TextBox 12"/>
-          <p:cNvSpPr txBox="1"/>
-          <p:nvPr/>
-        </p:nvSpPr>
-        <p:spPr>
-          <a:xfrm>
-            <a:off x="6675120" y="2194560"/>
-            <a:ext cx="5303520" cy="777240"/>
-          </a:xfrm>
-          <a:prstGeom prst="rect">
-            <a:avLst/>
-          </a:prstGeom>
-          <a:noFill/>
-        </p:spPr>
-        <p:txBody>
-          <a:bodyPr wrap="square">
-            <a:spAutoFit/>
-          </a:bodyPr>
-          <a:lstStyle/>
-          <a:p>
-            <a:pPr algn="l"/>
-            <a:r>
-              <a:rPr sz="1600" b="0" i="0">
+            <a:pPr>
+              <a:spcBef>
+                <a:spcPts val="1800"/>
+              </a:spcBef>
+            </a:pPr>
+            <a:r>
+              <a:rPr sz="2000">
                 <a:solidFill>
                   <a:srgbClr val="222233"/>
                 </a:solidFill>
               </a:rPr>
-              <a:t>Left sidebar --&gt; search dialog   /   Right --&gt; BottomSheet</a:t>
-            </a:r>
-          </a:p>
-        </p:txBody>
-      </p:sp>
-      <p:sp>
-        <p:nvSpPr>
-          <p:cNvPr id="14" name="Rectangle 13"/>
-          <p:cNvSpPr/>
-          <p:nvPr/>
-        </p:nvSpPr>
-        <p:spPr>
-          <a:xfrm>
-            <a:off x="274320" y="3200400"/>
-            <a:ext cx="5669280" cy="1920240"/>
-          </a:xfrm>
-          <a:prstGeom prst="rect">
-            <a:avLst/>
-          </a:prstGeom>
-          <a:solidFill>
-            <a:srgbClr val="F4F6F9"/>
-          </a:solidFill>
-          <a:ln>
-            <a:noFill/>
-          </a:ln>
-        </p:spPr>
-        <p:style>
-          <a:lnRef idx="1">
-            <a:schemeClr val="accent1"/>
-          </a:lnRef>
-          <a:fillRef idx="3">
-            <a:schemeClr val="accent1"/>
-          </a:fillRef>
-          <a:effectRef idx="2">
-            <a:schemeClr val="accent1"/>
-          </a:effectRef>
-          <a:fontRef idx="minor">
-            <a:schemeClr val="lt1"/>
-          </a:fontRef>
-        </p:style>
-        <p:txBody>
-          <a:bodyPr rtlCol="0" anchor="ctr"/>
-          <a:lstStyle/>
-          <a:p>
-            <a:pPr algn="ctr"/>
-            <a:endParaRPr/>
-          </a:p>
-        </p:txBody>
-      </p:sp>
-      <p:sp>
-        <p:nvSpPr>
-          <p:cNvPr id="15" name="Rectangle 14"/>
-          <p:cNvSpPr/>
-          <p:nvPr/>
-        </p:nvSpPr>
-        <p:spPr>
-          <a:xfrm>
-            <a:off x="274320" y="3200400"/>
-            <a:ext cx="182880" cy="1920240"/>
-          </a:xfrm>
-          <a:prstGeom prst="rect">
-            <a:avLst/>
-          </a:prstGeom>
-          <a:solidFill>
-            <a:srgbClr val="8E44AD"/>
-          </a:solidFill>
-          <a:ln>
-            <a:noFill/>
-          </a:ln>
-        </p:spPr>
-        <p:style>
-          <a:lnRef idx="1">
-            <a:schemeClr val="accent1"/>
-          </a:lnRef>
-          <a:fillRef idx="3">
-            <a:schemeClr val="accent1"/>
-          </a:fillRef>
-          <a:effectRef idx="2">
-            <a:schemeClr val="accent1"/>
-          </a:effectRef>
-          <a:fontRef idx="minor">
-            <a:schemeClr val="lt1"/>
-          </a:fontRef>
-        </p:style>
-        <p:txBody>
-          <a:bodyPr rtlCol="0" anchor="ctr"/>
-          <a:lstStyle/>
-          <a:p>
-            <a:pPr algn="ctr"/>
-            <a:endParaRPr/>
-          </a:p>
-        </p:txBody>
-      </p:sp>
-      <p:sp>
-        <p:nvSpPr>
-          <p:cNvPr id="16" name="TextBox 15"/>
-          <p:cNvSpPr txBox="1"/>
-          <p:nvPr/>
-        </p:nvSpPr>
-        <p:spPr>
-          <a:xfrm>
-            <a:off x="566928" y="3310128"/>
-            <a:ext cx="5303520" cy="384048"/>
-          </a:xfrm>
-          <a:prstGeom prst="rect">
-            <a:avLst/>
-          </a:prstGeom>
-          <a:noFill/>
-        </p:spPr>
-        <p:txBody>
-          <a:bodyPr wrap="square">
-            <a:spAutoFit/>
-          </a:bodyPr>
-          <a:lstStyle/>
-          <a:p>
-            <a:pPr algn="l"/>
-            <a:r>
-              <a:rPr sz="1700" b="1" i="0">
-                <a:solidFill>
-                  <a:srgbClr val="1C3557"/>
-                </a:solidFill>
-              </a:rPr>
-              <a:t>Missing Version Catalog</a:t>
-            </a:r>
-          </a:p>
-        </p:txBody>
-      </p:sp>
-      <p:sp>
-        <p:nvSpPr>
-          <p:cNvPr id="17" name="TextBox 16"/>
-          <p:cNvSpPr txBox="1"/>
-          <p:nvPr/>
-        </p:nvSpPr>
-        <p:spPr>
-          <a:xfrm>
-            <a:off x="566928" y="3730752"/>
-            <a:ext cx="5303520" cy="457200"/>
-          </a:xfrm>
-          <a:prstGeom prst="rect">
-            <a:avLst/>
-          </a:prstGeom>
-          <a:noFill/>
-        </p:spPr>
-        <p:txBody>
-          <a:bodyPr wrap="square">
-            <a:spAutoFit/>
-          </a:bodyPr>
-          <a:lstStyle/>
-          <a:p>
-            <a:pPr algn="l"/>
-            <a:r>
-              <a:rPr sz="1600" b="0" i="1">
-                <a:solidFill>
-                  <a:srgbClr val="993322"/>
-                </a:solidFill>
-              </a:rPr>
-              <a:t>gradle/ was gitignored -- build broken</a:t>
-            </a:r>
-          </a:p>
-        </p:txBody>
-      </p:sp>
-      <p:sp>
-        <p:nvSpPr>
-          <p:cNvPr id="18" name="TextBox 17"/>
-          <p:cNvSpPr txBox="1"/>
-          <p:nvPr/>
-        </p:nvSpPr>
-        <p:spPr>
-          <a:xfrm>
-            <a:off x="566928" y="4224528"/>
-            <a:ext cx="5303520" cy="777240"/>
-          </a:xfrm>
-          <a:prstGeom prst="rect">
-            <a:avLst/>
-          </a:prstGeom>
-          <a:noFill/>
-        </p:spPr>
-        <p:txBody>
-          <a:bodyPr wrap="square">
-            <a:spAutoFit/>
-          </a:bodyPr>
-          <a:lstStyle/>
-          <a:p>
-            <a:pPr algn="l"/>
-            <a:r>
-              <a:rPr sz="1600" b="0" i="0">
+              <a:t>  AI made this migration feasible in under a week</a:t>
+            </a:r>
+          </a:p>
+          <a:p>
+            <a:pPr>
+              <a:spcBef>
+                <a:spcPts val="1800"/>
+              </a:spcBef>
+            </a:pPr>
+            <a:r>
+              <a:rPr sz="2000">
                 <a:solidFill>
                   <a:srgbClr val="222233"/>
                 </a:solidFill>
               </a:rPr>
-              <a:t>Fixed .gitignore, recreated libs.versions.toml</a:t>
-            </a:r>
-          </a:p>
-        </p:txBody>
-      </p:sp>
-      <p:sp>
-        <p:nvSpPr>
-          <p:cNvPr id="19" name="Rectangle 18"/>
-          <p:cNvSpPr/>
-          <p:nvPr/>
-        </p:nvSpPr>
-        <p:spPr>
-          <a:xfrm>
-            <a:off x="6382512" y="3200400"/>
-            <a:ext cx="5669280" cy="1920240"/>
-          </a:xfrm>
-          <a:prstGeom prst="rect">
-            <a:avLst/>
-          </a:prstGeom>
-          <a:solidFill>
-            <a:srgbClr val="F4F6F9"/>
-          </a:solidFill>
-          <a:ln>
-            <a:noFill/>
-          </a:ln>
-        </p:spPr>
-        <p:style>
-          <a:lnRef idx="1">
-            <a:schemeClr val="accent1"/>
-          </a:lnRef>
-          <a:fillRef idx="3">
-            <a:schemeClr val="accent1"/>
-          </a:fillRef>
-          <a:effectRef idx="2">
-            <a:schemeClr val="accent1"/>
-          </a:effectRef>
-          <a:fontRef idx="minor">
-            <a:schemeClr val="lt1"/>
-          </a:fontRef>
-        </p:style>
-        <p:txBody>
-          <a:bodyPr rtlCol="0" anchor="ctr"/>
-          <a:lstStyle/>
-          <a:p>
-            <a:pPr algn="ctr"/>
-            <a:endParaRPr/>
-          </a:p>
-        </p:txBody>
-      </p:sp>
-      <p:sp>
-        <p:nvSpPr>
-          <p:cNvPr id="20" name="Rectangle 19"/>
-          <p:cNvSpPr/>
-          <p:nvPr/>
-        </p:nvSpPr>
-        <p:spPr>
-          <a:xfrm>
-            <a:off x="6382512" y="3200400"/>
-            <a:ext cx="182880" cy="1920240"/>
-          </a:xfrm>
-          <a:prstGeom prst="rect">
-            <a:avLst/>
-          </a:prstGeom>
-          <a:solidFill>
-            <a:srgbClr val="3DDC84"/>
-          </a:solidFill>
-          <a:ln>
-            <a:noFill/>
-          </a:ln>
-        </p:spPr>
-        <p:style>
-          <a:lnRef idx="1">
-            <a:schemeClr val="accent1"/>
-          </a:lnRef>
-          <a:fillRef idx="3">
-            <a:schemeClr val="accent1"/>
-          </a:fillRef>
-          <a:effectRef idx="2">
-            <a:schemeClr val="accent1"/>
-          </a:effectRef>
-          <a:fontRef idx="minor">
-            <a:schemeClr val="lt1"/>
-          </a:fontRef>
-        </p:style>
-        <p:txBody>
-          <a:bodyPr rtlCol="0" anchor="ctr"/>
-          <a:lstStyle/>
-          <a:p>
-            <a:pPr algn="ctr"/>
-            <a:endParaRPr/>
-          </a:p>
-        </p:txBody>
-      </p:sp>
-      <p:sp>
-        <p:nvSpPr>
-          <p:cNvPr id="21" name="TextBox 20"/>
-          <p:cNvSpPr txBox="1"/>
-          <p:nvPr/>
-        </p:nvSpPr>
-        <p:spPr>
-          <a:xfrm>
-            <a:off x="6675120" y="3310128"/>
-            <a:ext cx="5303520" cy="384048"/>
-          </a:xfrm>
-          <a:prstGeom prst="rect">
-            <a:avLst/>
-          </a:prstGeom>
-          <a:noFill/>
-        </p:spPr>
-        <p:txBody>
-          <a:bodyPr wrap="square">
-            <a:spAutoFit/>
-          </a:bodyPr>
-          <a:lstStyle/>
-          <a:p>
-            <a:pPr algn="l"/>
-            <a:r>
-              <a:rPr sz="1700" b="1" i="0">
-                <a:solidFill>
-                  <a:srgbClr val="1C3557"/>
-                </a:solidFill>
-              </a:rPr>
-              <a:t>State management</a:t>
-            </a:r>
-          </a:p>
-        </p:txBody>
-      </p:sp>
-      <p:sp>
-        <p:nvSpPr>
-          <p:cNvPr id="22" name="TextBox 21"/>
-          <p:cNvSpPr txBox="1"/>
-          <p:nvPr/>
-        </p:nvSpPr>
-        <p:spPr>
-          <a:xfrm>
-            <a:off x="6675120" y="3730752"/>
-            <a:ext cx="5303520" cy="457200"/>
-          </a:xfrm>
-          <a:prstGeom prst="rect">
-            <a:avLst/>
-          </a:prstGeom>
-          <a:noFill/>
-        </p:spPr>
-        <p:txBody>
-          <a:bodyPr wrap="square">
-            <a:spAutoFit/>
-          </a:bodyPr>
-          <a:lstStyle/>
-          <a:p>
-            <a:pPr algn="l"/>
-            <a:r>
-              <a:rPr sz="1600" b="0" i="1">
-                <a:solidFill>
-                  <a:srgbClr val="993322"/>
-                </a:solidFill>
-              </a:rPr>
-              <a:t>No @EnvironmentObject in Compose</a:t>
-            </a:r>
-          </a:p>
-        </p:txBody>
-      </p:sp>
-      <p:sp>
-        <p:nvSpPr>
-          <p:cNvPr id="23" name="TextBox 22"/>
-          <p:cNvSpPr txBox="1"/>
-          <p:nvPr/>
-        </p:nvSpPr>
-        <p:spPr>
-          <a:xfrm>
-            <a:off x="6675120" y="4224528"/>
-            <a:ext cx="5303520" cy="777240"/>
-          </a:xfrm>
-          <a:prstGeom prst="rect">
-            <a:avLst/>
-          </a:prstGeom>
-          <a:noFill/>
-        </p:spPr>
-        <p:txBody>
-          <a:bodyPr wrap="square">
-            <a:spAutoFit/>
-          </a:bodyPr>
-          <a:lstStyle/>
-          <a:p>
-            <a:pPr algn="l"/>
-            <a:r>
-              <a:rPr sz="1600" b="0" i="0">
+              <a:t>  Claude produced clean, idiomatic Kotlin</a:t>
+            </a:r>
+          </a:p>
+          <a:p>
+            <a:pPr>
+              <a:spcBef>
+                <a:spcPts val="1800"/>
+              </a:spcBef>
+            </a:pPr>
+            <a:r>
+              <a:rPr sz="2000">
                 <a:solidFill>
                   <a:srgbClr val="222233"/>
                 </a:solidFill>
               </a:rPr>
-              <a:t>ViewModel + StateFlow + collectAsState()</a:t>
+              <a:t>  Workflow: AI drafts  --  Human reviews  --  AI fixes</a:t>
             </a:r>
           </a:p>
         </p:txBody>
@@ -5826,1073 +6152,6 @@
 </file>
 
 <file path=ppt/slides/slide13.xml><?xml version="1.0" encoding="utf-8"?>
-<p:sld xmlns:a="http://schemas.openxmlformats.org/drawingml/2006/main" xmlns:r="http://schemas.openxmlformats.org/officeDocument/2006/relationships" xmlns:p="http://schemas.openxmlformats.org/presentationml/2006/main">
-  <p:cSld>
-    <p:bg>
-      <p:bgPr>
-        <a:solidFill>
-          <a:srgbClr val="FFFFFF"/>
-        </a:solidFill>
-        <a:effectLst/>
-      </p:bgPr>
-    </p:bg>
-    <p:spTree>
-      <p:nvGrpSpPr>
-        <p:cNvPr id="1" name=""/>
-        <p:cNvGrpSpPr/>
-        <p:nvPr/>
-      </p:nvGrpSpPr>
-      <p:grpSpPr>
-        <a:xfrm>
-          <a:off x="0" y="0"/>
-          <a:ext cx="0" cy="0"/>
-          <a:chOff x="0" y="0"/>
-          <a:chExt cx="0" cy="0"/>
-        </a:xfrm>
-      </p:grpSpPr>
-      <p:sp>
-        <p:nvSpPr>
-          <p:cNvPr id="2" name="Rectangle 1"/>
-          <p:cNvSpPr/>
-          <p:nvPr/>
-        </p:nvSpPr>
-        <p:spPr>
-          <a:xfrm>
-            <a:off x="0" y="0"/>
-            <a:ext cx="12188952" cy="1097280"/>
-          </a:xfrm>
-          <a:prstGeom prst="rect">
-            <a:avLst/>
-          </a:prstGeom>
-          <a:solidFill>
-            <a:srgbClr val="1C3557"/>
-          </a:solidFill>
-          <a:ln>
-            <a:noFill/>
-          </a:ln>
-        </p:spPr>
-        <p:style>
-          <a:lnRef idx="1">
-            <a:schemeClr val="accent1"/>
-          </a:lnRef>
-          <a:fillRef idx="3">
-            <a:schemeClr val="accent1"/>
-          </a:fillRef>
-          <a:effectRef idx="2">
-            <a:schemeClr val="accent1"/>
-          </a:effectRef>
-          <a:fontRef idx="minor">
-            <a:schemeClr val="lt1"/>
-          </a:fontRef>
-        </p:style>
-        <p:txBody>
-          <a:bodyPr rtlCol="0" anchor="ctr"/>
-          <a:lstStyle/>
-          <a:p>
-            <a:pPr algn="ctr"/>
-            <a:endParaRPr/>
-          </a:p>
-        </p:txBody>
-      </p:sp>
-      <p:sp>
-        <p:nvSpPr>
-          <p:cNvPr id="3" name="TextBox 2"/>
-          <p:cNvSpPr txBox="1"/>
-          <p:nvPr/>
-        </p:nvSpPr>
-        <p:spPr>
-          <a:xfrm>
-            <a:off x="411480" y="201168"/>
-            <a:ext cx="11430000" cy="777240"/>
-          </a:xfrm>
-          <a:prstGeom prst="rect">
-            <a:avLst/>
-          </a:prstGeom>
-          <a:noFill/>
-        </p:spPr>
-        <p:txBody>
-          <a:bodyPr wrap="square">
-            <a:spAutoFit/>
-          </a:bodyPr>
-          <a:lstStyle/>
-          <a:p>
-            <a:pPr algn="l"/>
-            <a:r>
-              <a:rPr sz="3200" b="1" i="0">
-                <a:solidFill>
-                  <a:srgbClr val="FFFFFF"/>
-                </a:solidFill>
-              </a:rPr>
-              <a:t>Results &amp; Conclusion</a:t>
-            </a:r>
-          </a:p>
-        </p:txBody>
-      </p:sp>
-      <p:sp>
-        <p:nvSpPr>
-          <p:cNvPr id="4" name="Rectangle 3"/>
-          <p:cNvSpPr/>
-          <p:nvPr/>
-        </p:nvSpPr>
-        <p:spPr>
-          <a:xfrm>
-            <a:off x="347472" y="1170432"/>
-            <a:ext cx="2103120" cy="1554480"/>
-          </a:xfrm>
-          <a:prstGeom prst="rect">
-            <a:avLst/>
-          </a:prstGeom>
-          <a:solidFill>
-            <a:srgbClr val="1C3557"/>
-          </a:solidFill>
-          <a:ln>
-            <a:noFill/>
-          </a:ln>
-        </p:spPr>
-        <p:style>
-          <a:lnRef idx="1">
-            <a:schemeClr val="accent1"/>
-          </a:lnRef>
-          <a:fillRef idx="3">
-            <a:schemeClr val="accent1"/>
-          </a:fillRef>
-          <a:effectRef idx="2">
-            <a:schemeClr val="accent1"/>
-          </a:effectRef>
-          <a:fontRef idx="minor">
-            <a:schemeClr val="lt1"/>
-          </a:fontRef>
-        </p:style>
-        <p:txBody>
-          <a:bodyPr rtlCol="0" anchor="ctr"/>
-          <a:lstStyle/>
-          <a:p>
-            <a:pPr algn="ctr"/>
-            <a:endParaRPr/>
-          </a:p>
-        </p:txBody>
-      </p:sp>
-      <p:sp>
-        <p:nvSpPr>
-          <p:cNvPr id="5" name="TextBox 4"/>
-          <p:cNvSpPr txBox="1"/>
-          <p:nvPr/>
-        </p:nvSpPr>
-        <p:spPr>
-          <a:xfrm>
-            <a:off x="347472" y="1216152"/>
-            <a:ext cx="2103120" cy="804672"/>
-          </a:xfrm>
-          <a:prstGeom prst="rect">
-            <a:avLst/>
-          </a:prstGeom>
-          <a:noFill/>
-        </p:spPr>
-        <p:txBody>
-          <a:bodyPr wrap="square">
-            <a:spAutoFit/>
-          </a:bodyPr>
-          <a:lstStyle/>
-          <a:p>
-            <a:pPr algn="ctr"/>
-            <a:r>
-              <a:rPr sz="4000" b="1" i="0">
-                <a:solidFill>
-                  <a:srgbClr val="4A90E2"/>
-                </a:solidFill>
-              </a:rPr>
-              <a:t>10+</a:t>
-            </a:r>
-          </a:p>
-        </p:txBody>
-      </p:sp>
-      <p:sp>
-        <p:nvSpPr>
-          <p:cNvPr id="6" name="TextBox 5"/>
-          <p:cNvSpPr txBox="1"/>
-          <p:nvPr/>
-        </p:nvSpPr>
-        <p:spPr>
-          <a:xfrm>
-            <a:off x="347472" y="1993392"/>
-            <a:ext cx="2103120" cy="658368"/>
-          </a:xfrm>
-          <a:prstGeom prst="rect">
-            <a:avLst/>
-          </a:prstGeom>
-          <a:noFill/>
-        </p:spPr>
-        <p:txBody>
-          <a:bodyPr wrap="square">
-            <a:spAutoFit/>
-          </a:bodyPr>
-          <a:lstStyle/>
-          <a:p>
-            <a:pPr algn="ctr"/>
-            <a:r>
-              <a:rPr sz="1400" b="0" i="0">
-                <a:solidFill>
-                  <a:srgbClr val="FFFFFF"/>
-                </a:solidFill>
-              </a:rPr>
-              <a:t>Swift files
-analysed</a:t>
-            </a:r>
-          </a:p>
-        </p:txBody>
-      </p:sp>
-      <p:sp>
-        <p:nvSpPr>
-          <p:cNvPr id="7" name="Rectangle 6"/>
-          <p:cNvSpPr/>
-          <p:nvPr/>
-        </p:nvSpPr>
-        <p:spPr>
-          <a:xfrm>
-            <a:off x="2615184" y="1170432"/>
-            <a:ext cx="2103120" cy="1554480"/>
-          </a:xfrm>
-          <a:prstGeom prst="rect">
-            <a:avLst/>
-          </a:prstGeom>
-          <a:solidFill>
-            <a:srgbClr val="1C3557"/>
-          </a:solidFill>
-          <a:ln>
-            <a:noFill/>
-          </a:ln>
-        </p:spPr>
-        <p:style>
-          <a:lnRef idx="1">
-            <a:schemeClr val="accent1"/>
-          </a:lnRef>
-          <a:fillRef idx="3">
-            <a:schemeClr val="accent1"/>
-          </a:fillRef>
-          <a:effectRef idx="2">
-            <a:schemeClr val="accent1"/>
-          </a:effectRef>
-          <a:fontRef idx="minor">
-            <a:schemeClr val="lt1"/>
-          </a:fontRef>
-        </p:style>
-        <p:txBody>
-          <a:bodyPr rtlCol="0" anchor="ctr"/>
-          <a:lstStyle/>
-          <a:p>
-            <a:pPr algn="ctr"/>
-            <a:endParaRPr/>
-          </a:p>
-        </p:txBody>
-      </p:sp>
-      <p:sp>
-        <p:nvSpPr>
-          <p:cNvPr id="8" name="TextBox 7"/>
-          <p:cNvSpPr txBox="1"/>
-          <p:nvPr/>
-        </p:nvSpPr>
-        <p:spPr>
-          <a:xfrm>
-            <a:off x="2615184" y="1216152"/>
-            <a:ext cx="2103120" cy="804672"/>
-          </a:xfrm>
-          <a:prstGeom prst="rect">
-            <a:avLst/>
-          </a:prstGeom>
-          <a:noFill/>
-        </p:spPr>
-        <p:txBody>
-          <a:bodyPr wrap="square">
-            <a:spAutoFit/>
-          </a:bodyPr>
-          <a:lstStyle/>
-          <a:p>
-            <a:pPr algn="ctr"/>
-            <a:r>
-              <a:rPr sz="4000" b="1" i="0">
-                <a:solidFill>
-                  <a:srgbClr val="4A90E2"/>
-                </a:solidFill>
-              </a:rPr>
-              <a:t>13</a:t>
-            </a:r>
-          </a:p>
-        </p:txBody>
-      </p:sp>
-      <p:sp>
-        <p:nvSpPr>
-          <p:cNvPr id="9" name="TextBox 8"/>
-          <p:cNvSpPr txBox="1"/>
-          <p:nvPr/>
-        </p:nvSpPr>
-        <p:spPr>
-          <a:xfrm>
-            <a:off x="2615184" y="1993392"/>
-            <a:ext cx="2103120" cy="658368"/>
-          </a:xfrm>
-          <a:prstGeom prst="rect">
-            <a:avLst/>
-          </a:prstGeom>
-          <a:noFill/>
-        </p:spPr>
-        <p:txBody>
-          <a:bodyPr wrap="square">
-            <a:spAutoFit/>
-          </a:bodyPr>
-          <a:lstStyle/>
-          <a:p>
-            <a:pPr algn="ctr"/>
-            <a:r>
-              <a:rPr sz="1400" b="0" i="0">
-                <a:solidFill>
-                  <a:srgbClr val="FFFFFF"/>
-                </a:solidFill>
-              </a:rPr>
-              <a:t>Kotlin files
-created</a:t>
-            </a:r>
-          </a:p>
-        </p:txBody>
-      </p:sp>
-      <p:sp>
-        <p:nvSpPr>
-          <p:cNvPr id="10" name="Rectangle 9"/>
-          <p:cNvSpPr/>
-          <p:nvPr/>
-        </p:nvSpPr>
-        <p:spPr>
-          <a:xfrm>
-            <a:off x="4882896" y="1170432"/>
-            <a:ext cx="2103120" cy="1554480"/>
-          </a:xfrm>
-          <a:prstGeom prst="rect">
-            <a:avLst/>
-          </a:prstGeom>
-          <a:solidFill>
-            <a:srgbClr val="1C3557"/>
-          </a:solidFill>
-          <a:ln>
-            <a:noFill/>
-          </a:ln>
-        </p:spPr>
-        <p:style>
-          <a:lnRef idx="1">
-            <a:schemeClr val="accent1"/>
-          </a:lnRef>
-          <a:fillRef idx="3">
-            <a:schemeClr val="accent1"/>
-          </a:fillRef>
-          <a:effectRef idx="2">
-            <a:schemeClr val="accent1"/>
-          </a:effectRef>
-          <a:fontRef idx="minor">
-            <a:schemeClr val="lt1"/>
-          </a:fontRef>
-        </p:style>
-        <p:txBody>
-          <a:bodyPr rtlCol="0" anchor="ctr"/>
-          <a:lstStyle/>
-          <a:p>
-            <a:pPr algn="ctr"/>
-            <a:endParaRPr/>
-          </a:p>
-        </p:txBody>
-      </p:sp>
-      <p:sp>
-        <p:nvSpPr>
-          <p:cNvPr id="11" name="TextBox 10"/>
-          <p:cNvSpPr txBox="1"/>
-          <p:nvPr/>
-        </p:nvSpPr>
-        <p:spPr>
-          <a:xfrm>
-            <a:off x="4882896" y="1216152"/>
-            <a:ext cx="2103120" cy="804672"/>
-          </a:xfrm>
-          <a:prstGeom prst="rect">
-            <a:avLst/>
-          </a:prstGeom>
-          <a:noFill/>
-        </p:spPr>
-        <p:txBody>
-          <a:bodyPr wrap="square">
-            <a:spAutoFit/>
-          </a:bodyPr>
-          <a:lstStyle/>
-          <a:p>
-            <a:pPr algn="ctr"/>
-            <a:r>
-              <a:rPr sz="4000" b="1" i="0">
-                <a:solidFill>
-                  <a:srgbClr val="4A90E2"/>
-                </a:solidFill>
-              </a:rPr>
-              <a:t>~95%</a:t>
-            </a:r>
-          </a:p>
-        </p:txBody>
-      </p:sp>
-      <p:sp>
-        <p:nvSpPr>
-          <p:cNvPr id="12" name="TextBox 11"/>
-          <p:cNvSpPr txBox="1"/>
-          <p:nvPr/>
-        </p:nvSpPr>
-        <p:spPr>
-          <a:xfrm>
-            <a:off x="4882896" y="1993392"/>
-            <a:ext cx="2103120" cy="658368"/>
-          </a:xfrm>
-          <a:prstGeom prst="rect">
-            <a:avLst/>
-          </a:prstGeom>
-          <a:noFill/>
-        </p:spPr>
-        <p:txBody>
-          <a:bodyPr wrap="square">
-            <a:spAutoFit/>
-          </a:bodyPr>
-          <a:lstStyle/>
-          <a:p>
-            <a:pPr algn="ctr"/>
-            <a:r>
-              <a:rPr sz="1400" b="0" i="0">
-                <a:solidFill>
-                  <a:srgbClr val="FFFFFF"/>
-                </a:solidFill>
-              </a:rPr>
-              <a:t>Feature parity</a:t>
-            </a:r>
-          </a:p>
-        </p:txBody>
-      </p:sp>
-      <p:sp>
-        <p:nvSpPr>
-          <p:cNvPr id="13" name="Rectangle 12"/>
-          <p:cNvSpPr/>
-          <p:nvPr/>
-        </p:nvSpPr>
-        <p:spPr>
-          <a:xfrm>
-            <a:off x="7150608" y="1170432"/>
-            <a:ext cx="2103120" cy="1554480"/>
-          </a:xfrm>
-          <a:prstGeom prst="rect">
-            <a:avLst/>
-          </a:prstGeom>
-          <a:solidFill>
-            <a:srgbClr val="1C3557"/>
-          </a:solidFill>
-          <a:ln>
-            <a:noFill/>
-          </a:ln>
-        </p:spPr>
-        <p:style>
-          <a:lnRef idx="1">
-            <a:schemeClr val="accent1"/>
-          </a:lnRef>
-          <a:fillRef idx="3">
-            <a:schemeClr val="accent1"/>
-          </a:fillRef>
-          <a:effectRef idx="2">
-            <a:schemeClr val="accent1"/>
-          </a:effectRef>
-          <a:fontRef idx="minor">
-            <a:schemeClr val="lt1"/>
-          </a:fontRef>
-        </p:style>
-        <p:txBody>
-          <a:bodyPr rtlCol="0" anchor="ctr"/>
-          <a:lstStyle/>
-          <a:p>
-            <a:pPr algn="ctr"/>
-            <a:endParaRPr/>
-          </a:p>
-        </p:txBody>
-      </p:sp>
-      <p:sp>
-        <p:nvSpPr>
-          <p:cNvPr id="14" name="TextBox 13"/>
-          <p:cNvSpPr txBox="1"/>
-          <p:nvPr/>
-        </p:nvSpPr>
-        <p:spPr>
-          <a:xfrm>
-            <a:off x="7150608" y="1216152"/>
-            <a:ext cx="2103120" cy="707886"/>
-          </a:xfrm>
-          <a:prstGeom prst="rect">
-            <a:avLst/>
-          </a:prstGeom>
-          <a:noFill/>
-        </p:spPr>
-        <p:txBody>
-          <a:bodyPr wrap="square">
-            <a:spAutoFit/>
-          </a:bodyPr>
-          <a:lstStyle/>
-          <a:p>
-            <a:pPr algn="ctr"/>
-            <a:r>
-              <a:rPr lang="de-DE" sz="4000" b="1" dirty="0">
-                <a:solidFill>
-                  <a:srgbClr val="4A90E2"/>
-                </a:solidFill>
-              </a:rPr>
-              <a:t>&gt;400k</a:t>
-            </a:r>
-            <a:endParaRPr sz="4000" b="1" i="0" dirty="0">
-              <a:solidFill>
-                <a:srgbClr val="4A90E2"/>
-              </a:solidFill>
-            </a:endParaRPr>
-          </a:p>
-        </p:txBody>
-      </p:sp>
-      <p:sp>
-        <p:nvSpPr>
-          <p:cNvPr id="15" name="TextBox 14"/>
-          <p:cNvSpPr txBox="1"/>
-          <p:nvPr/>
-        </p:nvSpPr>
-        <p:spPr>
-          <a:xfrm>
-            <a:off x="7150608" y="1993392"/>
-            <a:ext cx="2103120" cy="523220"/>
-          </a:xfrm>
-          <a:prstGeom prst="rect">
-            <a:avLst/>
-          </a:prstGeom>
-          <a:noFill/>
-        </p:spPr>
-        <p:txBody>
-          <a:bodyPr wrap="square">
-            <a:spAutoFit/>
-          </a:bodyPr>
-          <a:lstStyle/>
-          <a:p>
-            <a:pPr algn="ctr"/>
-            <a:r>
-              <a:rPr lang="de-DE" sz="1400" b="0" i="0" dirty="0" err="1">
-                <a:solidFill>
-                  <a:srgbClr val="FFFFFF"/>
-                </a:solidFill>
-              </a:rPr>
-              <a:t>tokens</a:t>
-            </a:r>
-            <a:r>
-              <a:rPr sz="1400" b="0" i="0" dirty="0">
-                <a:solidFill>
-                  <a:srgbClr val="FFFFFF"/>
-                </a:solidFill>
-              </a:rPr>
-              <a:t>
-used</a:t>
-            </a:r>
-          </a:p>
-        </p:txBody>
-      </p:sp>
-      <p:sp>
-        <p:nvSpPr>
-          <p:cNvPr id="16" name="Rectangle 15"/>
-          <p:cNvSpPr/>
-          <p:nvPr/>
-        </p:nvSpPr>
-        <p:spPr>
-          <a:xfrm>
-            <a:off x="9418320" y="1170432"/>
-            <a:ext cx="2103120" cy="1554480"/>
-          </a:xfrm>
-          <a:prstGeom prst="rect">
-            <a:avLst/>
-          </a:prstGeom>
-          <a:solidFill>
-            <a:srgbClr val="1C3557"/>
-          </a:solidFill>
-          <a:ln>
-            <a:noFill/>
-          </a:ln>
-        </p:spPr>
-        <p:style>
-          <a:lnRef idx="1">
-            <a:schemeClr val="accent1"/>
-          </a:lnRef>
-          <a:fillRef idx="3">
-            <a:schemeClr val="accent1"/>
-          </a:fillRef>
-          <a:effectRef idx="2">
-            <a:schemeClr val="accent1"/>
-          </a:effectRef>
-          <a:fontRef idx="minor">
-            <a:schemeClr val="lt1"/>
-          </a:fontRef>
-        </p:style>
-        <p:txBody>
-          <a:bodyPr rtlCol="0" anchor="ctr"/>
-          <a:lstStyle/>
-          <a:p>
-            <a:pPr algn="ctr"/>
-            <a:endParaRPr/>
-          </a:p>
-        </p:txBody>
-      </p:sp>
-      <p:sp>
-        <p:nvSpPr>
-          <p:cNvPr id="17" name="TextBox 16"/>
-          <p:cNvSpPr txBox="1"/>
-          <p:nvPr/>
-        </p:nvSpPr>
-        <p:spPr>
-          <a:xfrm>
-            <a:off x="9418320" y="1216152"/>
-            <a:ext cx="2103120" cy="804672"/>
-          </a:xfrm>
-          <a:prstGeom prst="rect">
-            <a:avLst/>
-          </a:prstGeom>
-          <a:noFill/>
-        </p:spPr>
-        <p:txBody>
-          <a:bodyPr wrap="square">
-            <a:spAutoFit/>
-          </a:bodyPr>
-          <a:lstStyle/>
-          <a:p>
-            <a:pPr algn="ctr"/>
-            <a:r>
-              <a:rPr sz="4000" b="1" i="0" dirty="0">
-                <a:solidFill>
-                  <a:srgbClr val="4A90E2"/>
-                </a:solidFill>
-              </a:rPr>
-              <a:t>&lt;1 week</a:t>
-            </a:r>
-          </a:p>
-        </p:txBody>
-      </p:sp>
-      <p:sp>
-        <p:nvSpPr>
-          <p:cNvPr id="18" name="TextBox 17"/>
-          <p:cNvSpPr txBox="1"/>
-          <p:nvPr/>
-        </p:nvSpPr>
-        <p:spPr>
-          <a:xfrm>
-            <a:off x="9418320" y="1993392"/>
-            <a:ext cx="2103120" cy="658368"/>
-          </a:xfrm>
-          <a:prstGeom prst="rect">
-            <a:avLst/>
-          </a:prstGeom>
-          <a:noFill/>
-        </p:spPr>
-        <p:txBody>
-          <a:bodyPr wrap="square">
-            <a:spAutoFit/>
-          </a:bodyPr>
-          <a:lstStyle/>
-          <a:p>
-            <a:pPr algn="ctr"/>
-            <a:r>
-              <a:rPr sz="1400" b="0" i="0">
-                <a:solidFill>
-                  <a:srgbClr val="FFFFFF"/>
-                </a:solidFill>
-              </a:rPr>
-              <a:t>Migration time</a:t>
-            </a:r>
-          </a:p>
-        </p:txBody>
-      </p:sp>
-      <p:sp>
-        <p:nvSpPr>
-          <p:cNvPr id="19" name="Rectangle 18"/>
-          <p:cNvSpPr/>
-          <p:nvPr/>
-        </p:nvSpPr>
-        <p:spPr>
-          <a:xfrm>
-            <a:off x="320040" y="2907792"/>
-            <a:ext cx="5669280" cy="3703320"/>
-          </a:xfrm>
-          <a:prstGeom prst="rect">
-            <a:avLst/>
-          </a:prstGeom>
-          <a:solidFill>
-            <a:srgbClr val="F4F6F9"/>
-          </a:solidFill>
-          <a:ln>
-            <a:noFill/>
-          </a:ln>
-        </p:spPr>
-        <p:style>
-          <a:lnRef idx="1">
-            <a:schemeClr val="accent1"/>
-          </a:lnRef>
-          <a:fillRef idx="3">
-            <a:schemeClr val="accent1"/>
-          </a:fillRef>
-          <a:effectRef idx="2">
-            <a:schemeClr val="accent1"/>
-          </a:effectRef>
-          <a:fontRef idx="minor">
-            <a:schemeClr val="lt1"/>
-          </a:fontRef>
-        </p:style>
-        <p:txBody>
-          <a:bodyPr rtlCol="0" anchor="ctr"/>
-          <a:lstStyle/>
-          <a:p>
-            <a:pPr algn="ctr"/>
-            <a:endParaRPr/>
-          </a:p>
-        </p:txBody>
-      </p:sp>
-      <p:sp>
-        <p:nvSpPr>
-          <p:cNvPr id="20" name="Rectangle 19"/>
-          <p:cNvSpPr/>
-          <p:nvPr/>
-        </p:nvSpPr>
-        <p:spPr>
-          <a:xfrm>
-            <a:off x="320040" y="2907792"/>
-            <a:ext cx="5669280" cy="502920"/>
-          </a:xfrm>
-          <a:prstGeom prst="rect">
-            <a:avLst/>
-          </a:prstGeom>
-          <a:solidFill>
-            <a:srgbClr val="1C3557"/>
-          </a:solidFill>
-          <a:ln>
-            <a:noFill/>
-          </a:ln>
-        </p:spPr>
-        <p:style>
-          <a:lnRef idx="1">
-            <a:schemeClr val="accent1"/>
-          </a:lnRef>
-          <a:fillRef idx="3">
-            <a:schemeClr val="accent1"/>
-          </a:fillRef>
-          <a:effectRef idx="2">
-            <a:schemeClr val="accent1"/>
-          </a:effectRef>
-          <a:fontRef idx="minor">
-            <a:schemeClr val="lt1"/>
-          </a:fontRef>
-        </p:style>
-        <p:txBody>
-          <a:bodyPr rtlCol="0" anchor="ctr"/>
-          <a:lstStyle/>
-          <a:p>
-            <a:pPr algn="ctr"/>
-            <a:endParaRPr/>
-          </a:p>
-        </p:txBody>
-      </p:sp>
-      <p:sp>
-        <p:nvSpPr>
-          <p:cNvPr id="21" name="TextBox 20"/>
-          <p:cNvSpPr txBox="1"/>
-          <p:nvPr/>
-        </p:nvSpPr>
-        <p:spPr>
-          <a:xfrm>
-            <a:off x="320040" y="2935224"/>
-            <a:ext cx="5669280" cy="457200"/>
-          </a:xfrm>
-          <a:prstGeom prst="rect">
-            <a:avLst/>
-          </a:prstGeom>
-          <a:noFill/>
-        </p:spPr>
-        <p:txBody>
-          <a:bodyPr wrap="square">
-            <a:spAutoFit/>
-          </a:bodyPr>
-          <a:lstStyle/>
-          <a:p>
-            <a:pPr algn="ctr"/>
-            <a:r>
-              <a:rPr sz="1900" b="1" i="0">
-                <a:solidFill>
-                  <a:srgbClr val="FFFFFF"/>
-                </a:solidFill>
-              </a:rPr>
-              <a:t>What We Learned</a:t>
-            </a:r>
-          </a:p>
-        </p:txBody>
-      </p:sp>
-      <p:sp>
-        <p:nvSpPr>
-          <p:cNvPr id="22" name="TextBox 21"/>
-          <p:cNvSpPr txBox="1"/>
-          <p:nvPr/>
-        </p:nvSpPr>
-        <p:spPr>
-          <a:xfrm>
-            <a:off x="457200" y="3502152"/>
-            <a:ext cx="5394960" cy="2971800"/>
-          </a:xfrm>
-          <a:prstGeom prst="rect">
-            <a:avLst/>
-          </a:prstGeom>
-          <a:noFill/>
-        </p:spPr>
-        <p:txBody>
-          <a:bodyPr wrap="square">
-            <a:spAutoFit/>
-          </a:bodyPr>
-          <a:lstStyle/>
-          <a:p>
-            <a:pPr>
-              <a:spcBef>
-                <a:spcPts val="1800"/>
-              </a:spcBef>
-            </a:pPr>
-            <a:r>
-              <a:rPr sz="2000">
-                <a:solidFill>
-                  <a:srgbClr val="222233"/>
-                </a:solidFill>
-              </a:rPr>
-              <a:t>  AI excels at translating between similar frameworks</a:t>
-            </a:r>
-          </a:p>
-          <a:p>
-            <a:pPr>
-              <a:spcBef>
-                <a:spcPts val="1800"/>
-              </a:spcBef>
-            </a:pPr>
-            <a:r>
-              <a:rPr sz="2000">
-                <a:solidFill>
-                  <a:srgbClr val="222233"/>
-                </a:solidFill>
-              </a:rPr>
-              <a:t>  Iterative prompting beats one-shot generation</a:t>
-            </a:r>
-          </a:p>
-          <a:p>
-            <a:pPr>
-              <a:spcBef>
-                <a:spcPts val="1800"/>
-              </a:spcBef>
-            </a:pPr>
-            <a:r>
-              <a:rPr sz="2000">
-                <a:solidFill>
-                  <a:srgbClr val="222233"/>
-                </a:solidFill>
-              </a:rPr>
-              <a:t>  Human oversight is still essential for config &amp; APIs</a:t>
-            </a:r>
-          </a:p>
-        </p:txBody>
-      </p:sp>
-      <p:sp>
-        <p:nvSpPr>
-          <p:cNvPr id="23" name="Rectangle 22"/>
-          <p:cNvSpPr/>
-          <p:nvPr/>
-        </p:nvSpPr>
-        <p:spPr>
-          <a:xfrm>
-            <a:off x="6281928" y="2907792"/>
-            <a:ext cx="5669280" cy="3703320"/>
-          </a:xfrm>
-          <a:prstGeom prst="rect">
-            <a:avLst/>
-          </a:prstGeom>
-          <a:solidFill>
-            <a:srgbClr val="F4F6F9"/>
-          </a:solidFill>
-          <a:ln>
-            <a:noFill/>
-          </a:ln>
-        </p:spPr>
-        <p:style>
-          <a:lnRef idx="1">
-            <a:schemeClr val="accent1"/>
-          </a:lnRef>
-          <a:fillRef idx="3">
-            <a:schemeClr val="accent1"/>
-          </a:fillRef>
-          <a:effectRef idx="2">
-            <a:schemeClr val="accent1"/>
-          </a:effectRef>
-          <a:fontRef idx="minor">
-            <a:schemeClr val="lt1"/>
-          </a:fontRef>
-        </p:style>
-        <p:txBody>
-          <a:bodyPr rtlCol="0" anchor="ctr"/>
-          <a:lstStyle/>
-          <a:p>
-            <a:pPr algn="ctr"/>
-            <a:endParaRPr/>
-          </a:p>
-        </p:txBody>
-      </p:sp>
-      <p:sp>
-        <p:nvSpPr>
-          <p:cNvPr id="24" name="Rectangle 23"/>
-          <p:cNvSpPr/>
-          <p:nvPr/>
-        </p:nvSpPr>
-        <p:spPr>
-          <a:xfrm>
-            <a:off x="6281928" y="2907792"/>
-            <a:ext cx="5669280" cy="502920"/>
-          </a:xfrm>
-          <a:prstGeom prst="rect">
-            <a:avLst/>
-          </a:prstGeom>
-          <a:solidFill>
-            <a:srgbClr val="147A3A"/>
-          </a:solidFill>
-          <a:ln>
-            <a:noFill/>
-          </a:ln>
-        </p:spPr>
-        <p:style>
-          <a:lnRef idx="1">
-            <a:schemeClr val="accent1"/>
-          </a:lnRef>
-          <a:fillRef idx="3">
-            <a:schemeClr val="accent1"/>
-          </a:fillRef>
-          <a:effectRef idx="2">
-            <a:schemeClr val="accent1"/>
-          </a:effectRef>
-          <a:fontRef idx="minor">
-            <a:schemeClr val="lt1"/>
-          </a:fontRef>
-        </p:style>
-        <p:txBody>
-          <a:bodyPr rtlCol="0" anchor="ctr"/>
-          <a:lstStyle/>
-          <a:p>
-            <a:pPr algn="ctr"/>
-            <a:endParaRPr/>
-          </a:p>
-        </p:txBody>
-      </p:sp>
-      <p:sp>
-        <p:nvSpPr>
-          <p:cNvPr id="25" name="TextBox 24"/>
-          <p:cNvSpPr txBox="1"/>
-          <p:nvPr/>
-        </p:nvSpPr>
-        <p:spPr>
-          <a:xfrm>
-            <a:off x="6281928" y="2935224"/>
-            <a:ext cx="5669280" cy="457200"/>
-          </a:xfrm>
-          <a:prstGeom prst="rect">
-            <a:avLst/>
-          </a:prstGeom>
-          <a:noFill/>
-        </p:spPr>
-        <p:txBody>
-          <a:bodyPr wrap="square">
-            <a:spAutoFit/>
-          </a:bodyPr>
-          <a:lstStyle/>
-          <a:p>
-            <a:pPr algn="ctr"/>
-            <a:r>
-              <a:rPr sz="1900" b="1" i="0">
-                <a:solidFill>
-                  <a:srgbClr val="FFFFFF"/>
-                </a:solidFill>
-              </a:rPr>
-              <a:t>Verdict</a:t>
-            </a:r>
-          </a:p>
-        </p:txBody>
-      </p:sp>
-      <p:sp>
-        <p:nvSpPr>
-          <p:cNvPr id="26" name="TextBox 25"/>
-          <p:cNvSpPr txBox="1"/>
-          <p:nvPr/>
-        </p:nvSpPr>
-        <p:spPr>
-          <a:xfrm>
-            <a:off x="6419088" y="3502152"/>
-            <a:ext cx="5394960" cy="2971800"/>
-          </a:xfrm>
-          <a:prstGeom prst="rect">
-            <a:avLst/>
-          </a:prstGeom>
-          <a:noFill/>
-        </p:spPr>
-        <p:txBody>
-          <a:bodyPr wrap="square">
-            <a:spAutoFit/>
-          </a:bodyPr>
-          <a:lstStyle/>
-          <a:p>
-            <a:pPr>
-              <a:spcBef>
-                <a:spcPts val="1800"/>
-              </a:spcBef>
-            </a:pPr>
-            <a:r>
-              <a:rPr sz="2000">
-                <a:solidFill>
-                  <a:srgbClr val="222233"/>
-                </a:solidFill>
-              </a:rPr>
-              <a:t>  AI made this migration feasible in under a week</a:t>
-            </a:r>
-          </a:p>
-          <a:p>
-            <a:pPr>
-              <a:spcBef>
-                <a:spcPts val="1800"/>
-              </a:spcBef>
-            </a:pPr>
-            <a:r>
-              <a:rPr sz="2000">
-                <a:solidFill>
-                  <a:srgbClr val="222233"/>
-                </a:solidFill>
-              </a:rPr>
-              <a:t>  Claude produced clean, idiomatic Kotlin</a:t>
-            </a:r>
-          </a:p>
-          <a:p>
-            <a:pPr>
-              <a:spcBef>
-                <a:spcPts val="1800"/>
-              </a:spcBef>
-            </a:pPr>
-            <a:r>
-              <a:rPr sz="2000">
-                <a:solidFill>
-                  <a:srgbClr val="222233"/>
-                </a:solidFill>
-              </a:rPr>
-              <a:t>  Workflow: AI drafts  --  Human reviews  --  AI fixes</a:t>
-            </a:r>
-          </a:p>
-        </p:txBody>
-      </p:sp>
-    </p:spTree>
-  </p:cSld>
-  <p:clrMapOvr>
-    <a:masterClrMapping/>
-  </p:clrMapOvr>
-</p:sld>
-</file>
-
-<file path=ppt/slides/slide14.xml><?xml version="1.0" encoding="utf-8"?>
 <p:sld xmlns:a="http://schemas.openxmlformats.org/drawingml/2006/main" xmlns:r="http://schemas.openxmlformats.org/officeDocument/2006/relationships" xmlns:p="http://schemas.openxmlformats.org/presentationml/2006/main">
   <p:cSld>
     <p:bg>
@@ -10376,7 +9635,7 @@
         <p:spPr>
           <a:xfrm>
             <a:off x="502920" y="1920240"/>
-            <a:ext cx="5120640" cy="4480560"/>
+            <a:ext cx="5120640" cy="2139047"/>
           </a:xfrm>
           <a:prstGeom prst="rect">
             <a:avLst/>
@@ -10395,7 +9654,7 @@
               </a:spcBef>
             </a:pPr>
             <a:r>
-              <a:rPr sz="2200">
+              <a:rPr sz="2200" dirty="0">
                 <a:solidFill>
                   <a:srgbClr val="222233"/>
                 </a:solidFill>
@@ -10410,7 +9669,7 @@
               </a:spcBef>
             </a:pPr>
             <a:r>
-              <a:rPr sz="2200">
+              <a:rPr sz="2200" dirty="0">
                 <a:solidFill>
                   <a:srgbClr val="222233"/>
                 </a:solidFill>
@@ -10425,12 +9684,44 @@
               </a:spcBef>
             </a:pPr>
             <a:r>
-              <a:rPr sz="2200">
+              <a:rPr sz="2200" dirty="0">
                 <a:solidFill>
                   <a:srgbClr val="222233"/>
                 </a:solidFill>
               </a:rPr>
-              <a:t>  City search  +  oC / oF toggle</a:t>
+              <a:t>  City search  +  C</a:t>
+            </a:r>
+            <a:r>
+              <a:rPr lang="de-AT" sz="2200" dirty="0">
+                <a:solidFill>
+                  <a:srgbClr val="222233"/>
+                </a:solidFill>
+              </a:rPr>
+              <a:t>°</a:t>
+            </a:r>
+            <a:r>
+              <a:rPr sz="2200" dirty="0">
+                <a:solidFill>
+                  <a:srgbClr val="222233"/>
+                </a:solidFill>
+              </a:rPr>
+              <a:t> / F</a:t>
+            </a:r>
+            <a:r>
+              <a:rPr lang="de-AT" sz="2200" dirty="0">
+                <a:solidFill>
+                  <a:srgbClr val="222233"/>
+                </a:solidFill>
+              </a:rPr>
+              <a:t>°</a:t>
+            </a:r>
+            <a:r>
+              <a:rPr sz="2200" dirty="0">
+                <a:solidFill>
+                  <a:srgbClr val="222233"/>
+                </a:solidFill>
+              </a:rPr>
+              <a:t> toggle</a:t>
             </a:r>
           </a:p>
           <a:p>
@@ -10440,7 +9731,7 @@
               </a:spcBef>
             </a:pPr>
             <a:r>
-              <a:rPr sz="2200">
+              <a:rPr sz="2200" dirty="0">
                 <a:solidFill>
                   <a:srgbClr val="222233"/>
                 </a:solidFill>
@@ -12305,13 +11596,18 @@
           <a:p>
             <a:pPr algn="l"/>
             <a:r>
-              <a:rPr sz="1600" b="0" i="0">
+              <a:rPr sz="1600" b="0" i="0" dirty="0" err="1">
                 <a:solidFill>
                   <a:srgbClr val="222233"/>
                 </a:solidFill>
               </a:rPr>
               <a:t>AddLocationView</a:t>
             </a:r>
+            <a:endParaRPr sz="1600" b="0" i="0" dirty="0">
+              <a:solidFill>
+                <a:srgbClr val="222233"/>
+              </a:solidFill>
+            </a:endParaRPr>
           </a:p>
         </p:txBody>
       </p:sp>
@@ -12383,13 +11679,18 @@
           <a:p>
             <a:pPr algn="l"/>
             <a:r>
-              <a:rPr sz="1600" b="0" i="0">
+              <a:rPr sz="1600" b="0" i="0" dirty="0" err="1">
                 <a:solidFill>
                   <a:srgbClr val="222233"/>
                 </a:solidFill>
               </a:rPr>
               <a:t>AlertDialog</a:t>
             </a:r>
+            <a:endParaRPr sz="1600" b="0" i="0" dirty="0">
+              <a:solidFill>
+                <a:srgbClr val="222233"/>
+              </a:solidFill>
+            </a:endParaRPr>
           </a:p>
         </p:txBody>
       </p:sp>
@@ -13085,7 +12386,7 @@
           <a:p>
             <a:pPr algn="l"/>
             <a:r>
-              <a:rPr sz="1600" b="0" i="0">
+              <a:rPr sz="1600" b="0" i="0" dirty="0">
                 <a:solidFill>
                   <a:srgbClr val="222233"/>
                 </a:solidFill>
@@ -13319,13 +12620,18 @@
           <a:p>
             <a:pPr algn="l"/>
             <a:r>
-              <a:rPr sz="1600" b="0" i="0">
+              <a:rPr sz="1600" b="0" i="0" dirty="0" err="1">
                 <a:solidFill>
                   <a:srgbClr val="222233"/>
                 </a:solidFill>
               </a:rPr>
               <a:t>DataStore</a:t>
             </a:r>
+            <a:endParaRPr sz="1600" b="0" i="0" dirty="0">
+              <a:solidFill>
+                <a:srgbClr val="222233"/>
+              </a:solidFill>
+            </a:endParaRPr>
           </a:p>
         </p:txBody>
       </p:sp>

</xml_diff>

<commit_message>
final tweaks before presentation
</commit_message>
<xml_diff>
--- a/docs/WeatheryApp_Presentation.pptx
+++ b/docs/WeatheryApp_Presentation.pptx
@@ -7578,7 +7578,7 @@
         <p:spPr>
           <a:xfrm>
             <a:off x="6080760" y="1920240"/>
-            <a:ext cx="5577840" cy="4572000"/>
+            <a:ext cx="5577840" cy="2139047"/>
           </a:xfrm>
           <a:prstGeom prst="rect">
             <a:avLst/>
@@ -7597,13 +7597,26 @@
               </a:spcBef>
             </a:pPr>
             <a:r>
-              <a:rPr sz="2200">
+              <a:rPr sz="2200" dirty="0">
                 <a:solidFill>
                   <a:srgbClr val="222233"/>
                 </a:solidFill>
               </a:rPr>
-              <a:t>  Swift 5  +  SwiftUI</a:t>
-            </a:r>
+              <a:t>  Swift 5  +  </a:t>
+            </a:r>
+            <a:r>
+              <a:rPr sz="2200" dirty="0" err="1">
+                <a:solidFill>
+                  <a:srgbClr val="222233"/>
+                </a:solidFill>
+              </a:rPr>
+              <a:t>SwiftUI</a:t>
+            </a:r>
+            <a:endParaRPr sz="2200" dirty="0">
+              <a:solidFill>
+                <a:srgbClr val="222233"/>
+              </a:solidFill>
+            </a:endParaRPr>
           </a:p>
           <a:p>
             <a:pPr>
@@ -7612,13 +7625,26 @@
               </a:spcBef>
             </a:pPr>
             <a:r>
-              <a:rPr sz="2200">
+              <a:rPr lang="de-DE" sz="2200" dirty="0">
                 <a:solidFill>
                   <a:srgbClr val="222233"/>
                 </a:solidFill>
               </a:rPr>
-              <a:t>  URLSession  +  CoreLocation</a:t>
-            </a:r>
+              <a:t>  </a:t>
+            </a:r>
+            <a:r>
+              <a:rPr sz="2200" dirty="0" err="1">
+                <a:solidFill>
+                  <a:srgbClr val="222233"/>
+                </a:solidFill>
+              </a:rPr>
+              <a:t>CoreLocation</a:t>
+            </a:r>
+            <a:endParaRPr sz="2200" dirty="0">
+              <a:solidFill>
+                <a:srgbClr val="222233"/>
+              </a:solidFill>
+            </a:endParaRPr>
           </a:p>
           <a:p>
             <a:pPr>
@@ -7627,7 +7653,7 @@
               </a:spcBef>
             </a:pPr>
             <a:r>
-              <a:rPr sz="2200">
+              <a:rPr sz="2200" dirty="0">
                 <a:solidFill>
                   <a:srgbClr val="222233"/>
                 </a:solidFill>
@@ -7642,13 +7668,34 @@
               </a:spcBef>
             </a:pPr>
             <a:r>
-              <a:rPr sz="2200">
+              <a:rPr sz="2200" dirty="0">
                 <a:solidFill>
                   <a:srgbClr val="222233"/>
                 </a:solidFill>
               </a:rPr>
-              <a:t>  UserDefaults  +  async/await</a:t>
-            </a:r>
+              <a:t>  </a:t>
+            </a:r>
+            <a:r>
+              <a:rPr sz="2200" dirty="0" err="1">
+                <a:solidFill>
+                  <a:srgbClr val="222233"/>
+                </a:solidFill>
+              </a:rPr>
+              <a:t>UserDefault</a:t>
+            </a:r>
+            <a:r>
+              <a:rPr lang="de-DE" sz="2200" dirty="0">
+                <a:solidFill>
+                  <a:srgbClr val="222233"/>
+                </a:solidFill>
+              </a:rPr>
+              <a:t>s</a:t>
+            </a:r>
+            <a:endParaRPr sz="2200" dirty="0">
+              <a:solidFill>
+                <a:srgbClr val="222233"/>
+              </a:solidFill>
+            </a:endParaRPr>
           </a:p>
         </p:txBody>
       </p:sp>
@@ -12877,7 +12924,7 @@
         <p:spPr>
           <a:xfrm>
             <a:off x="475488" y="1810512"/>
-            <a:ext cx="5321808" cy="4663440"/>
+            <a:ext cx="5321808" cy="2708434"/>
           </a:xfrm>
           <a:prstGeom prst="rect">
             <a:avLst/>
@@ -12896,12 +12943,12 @@
               </a:spcBef>
             </a:pPr>
             <a:r>
-              <a:rPr sz="2000">
+              <a:rPr sz="2000" dirty="0">
                 <a:solidFill>
                   <a:srgbClr val="222233"/>
                 </a:solidFill>
               </a:rPr>
-              <a:t>  Swift to Kotlin translation: perfect first attempt</a:t>
+              <a:t>  Swift to Kotlin translation</a:t>
             </a:r>
           </a:p>
           <a:p>
@@ -12911,12 +12958,28 @@
               </a:spcBef>
             </a:pPr>
             <a:r>
-              <a:rPr sz="2000">
+              <a:rPr sz="2000" dirty="0">
                 <a:solidFill>
                   <a:srgbClr val="222233"/>
                 </a:solidFill>
               </a:rPr>
-              <a:t>  SwiftUI to Compose: clean mapping, same mental model</a:t>
+              <a:t>  </a:t>
+            </a:r>
+            <a:r>
+              <a:rPr sz="2000" dirty="0" err="1">
+                <a:solidFill>
+                  <a:srgbClr val="222233"/>
+                </a:solidFill>
+              </a:rPr>
+              <a:t>SwiftUI</a:t>
+            </a:r>
+            <a:r>
+              <a:rPr sz="2000" dirty="0">
+                <a:solidFill>
+                  <a:srgbClr val="222233"/>
+                </a:solidFill>
+              </a:rPr>
+              <a:t> to Compose: clean mapping, same mental model</a:t>
             </a:r>
           </a:p>
           <a:p>
@@ -12926,12 +12989,52 @@
               </a:spcBef>
             </a:pPr>
             <a:r>
-              <a:rPr sz="2000">
+              <a:rPr sz="2000" dirty="0">
                 <a:solidFill>
                   <a:srgbClr val="222233"/>
                 </a:solidFill>
               </a:rPr>
-              <a:t>  Architecture (MVVM + StateFlow) applied correctly</a:t>
+              <a:t>  Architecture (MVVM + </a:t>
+            </a:r>
+            <a:r>
+              <a:rPr sz="2000" dirty="0" err="1">
+                <a:solidFill>
+                  <a:srgbClr val="222233"/>
+                </a:solidFill>
+              </a:rPr>
+              <a:t>StateFlow</a:t>
+            </a:r>
+            <a:r>
+              <a:rPr sz="2000" dirty="0">
+                <a:solidFill>
+                  <a:srgbClr val="222233"/>
+                </a:solidFill>
+              </a:rPr>
+              <a:t>) </a:t>
+            </a:r>
+            <a:r>
+              <a:rPr sz="2000" dirty="0" err="1">
+                <a:solidFill>
+                  <a:srgbClr val="222233"/>
+                </a:solidFill>
+              </a:rPr>
+              <a:t>applie</a:t>
+            </a:r>
+            <a:r>
+              <a:rPr lang="de-DE" sz="2000" dirty="0">
+                <a:solidFill>
+                  <a:srgbClr val="222233"/>
+                </a:solidFill>
+              </a:rPr>
+              <a:t>d  </a:t>
+            </a:r>
+            <a:r>
+              <a:rPr sz="2000" dirty="0">
+                <a:solidFill>
+                  <a:srgbClr val="222233"/>
+                </a:solidFill>
+              </a:rPr>
+              <a:t>correctly</a:t>
             </a:r>
           </a:p>
           <a:p>
@@ -12941,12 +13044,12 @@
               </a:spcBef>
             </a:pPr>
             <a:r>
-              <a:rPr sz="2000">
+              <a:rPr sz="2000" dirty="0">
                 <a:solidFill>
                   <a:srgbClr val="222233"/>
                 </a:solidFill>
               </a:rPr>
-              <a:t>  Build errors fixed quickly by re-prompting</a:t>
+              <a:t>errors fixed quickly by re-prompting</a:t>
             </a:r>
           </a:p>
         </p:txBody>
@@ -13082,7 +13185,7 @@
         <p:spPr>
           <a:xfrm>
             <a:off x="6163056" y="1810512"/>
-            <a:ext cx="5577840" cy="4663440"/>
+            <a:ext cx="5577840" cy="3221395"/>
           </a:xfrm>
           <a:prstGeom prst="rect">
             <a:avLst/>
@@ -13101,12 +13204,12 @@
               </a:spcBef>
             </a:pPr>
             <a:r>
-              <a:rPr sz="2000">
+              <a:rPr sz="2000" dirty="0">
                 <a:solidFill>
                   <a:srgbClr val="222233"/>
                 </a:solidFill>
               </a:rPr>
-              <a:t>  Wrong API URL  (paid vs. free endpoint)</a:t>
+              <a:t>  Wrong API</a:t>
             </a:r>
           </a:p>
           <a:p>
@@ -13116,12 +13219,28 @@
               </a:spcBef>
             </a:pPr>
             <a:r>
-              <a:rPr sz="2000">
+              <a:rPr sz="2000" dirty="0">
                 <a:solidFill>
                   <a:srgbClr val="222233"/>
                 </a:solidFill>
               </a:rPr>
-              <a:t>  Gitignore accidentally excluded version catalog</a:t>
+              <a:t>  </a:t>
+            </a:r>
+            <a:r>
+              <a:rPr sz="2000" dirty="0" err="1">
+                <a:solidFill>
+                  <a:srgbClr val="222233"/>
+                </a:solidFill>
+              </a:rPr>
+              <a:t>WeatherKit</a:t>
+            </a:r>
+            <a:r>
+              <a:rPr sz="2000" dirty="0">
+                <a:solidFill>
+                  <a:srgbClr val="222233"/>
+                </a:solidFill>
+              </a:rPr>
+              <a:t> is Apple-only -- had to redirect AI</a:t>
             </a:r>
           </a:p>
           <a:p>
@@ -13131,13 +13250,18 @@
               </a:spcBef>
             </a:pPr>
             <a:r>
-              <a:rPr sz="2000">
+              <a:rPr sz="2000" dirty="0">
                 <a:solidFill>
                   <a:srgbClr val="222233"/>
                 </a:solidFill>
               </a:rPr>
-              <a:t>  WeatherKit is Apple-only -- had to redirect AI</a:t>
-            </a:r>
+              <a:t>  API key &amp; SDK path always set up manually</a:t>
+            </a:r>
+            <a:endParaRPr lang="de-DE" sz="2000" dirty="0">
+              <a:solidFill>
+                <a:srgbClr val="222233"/>
+              </a:solidFill>
+            </a:endParaRPr>
           </a:p>
           <a:p>
             <a:pPr>
@@ -13146,13 +13270,240 @@
               </a:spcBef>
             </a:pPr>
             <a:r>
-              <a:rPr sz="2000">
+              <a:rPr lang="de-DE" sz="2000" dirty="0">
                 <a:solidFill>
                   <a:srgbClr val="222233"/>
                 </a:solidFill>
               </a:rPr>
-              <a:t>  API key &amp; SDK path always set up manually</a:t>
-            </a:r>
+              <a:t> </a:t>
+            </a:r>
+            <a:r>
+              <a:rPr lang="de-DE" sz="2000" dirty="0" err="1">
+                <a:solidFill>
+                  <a:srgbClr val="222233"/>
+                </a:solidFill>
+              </a:rPr>
+              <a:t>Calculation</a:t>
+            </a:r>
+            <a:r>
+              <a:rPr lang="de-DE" sz="2000" dirty="0">
+                <a:solidFill>
+                  <a:srgbClr val="222233"/>
+                </a:solidFill>
+              </a:rPr>
+              <a:t> </a:t>
+            </a:r>
+            <a:r>
+              <a:rPr lang="de-DE" sz="2000" dirty="0" err="1">
+                <a:solidFill>
+                  <a:srgbClr val="222233"/>
+                </a:solidFill>
+              </a:rPr>
+              <a:t>of</a:t>
+            </a:r>
+            <a:r>
+              <a:rPr lang="de-DE" sz="2000" dirty="0">
+                <a:solidFill>
+                  <a:srgbClr val="222233"/>
+                </a:solidFill>
+              </a:rPr>
+              <a:t> C/F and </a:t>
+            </a:r>
+            <a:r>
+              <a:rPr lang="de-DE" sz="2000" dirty="0" err="1">
+                <a:solidFill>
+                  <a:srgbClr val="222233"/>
+                </a:solidFill>
+              </a:rPr>
+              <a:t>rerendering</a:t>
+            </a:r>
+            <a:r>
+              <a:rPr lang="de-DE" sz="2000" dirty="0">
+                <a:solidFill>
+                  <a:srgbClr val="222233"/>
+                </a:solidFill>
+              </a:rPr>
+              <a:t> UI</a:t>
+            </a:r>
+          </a:p>
+          <a:p>
+            <a:pPr>
+              <a:spcBef>
+                <a:spcPts val="2000"/>
+              </a:spcBef>
+            </a:pPr>
+            <a:r>
+              <a:rPr lang="de-DE" sz="2000" dirty="0">
+                <a:solidFill>
+                  <a:srgbClr val="222233"/>
+                </a:solidFill>
+              </a:rPr>
+              <a:t> (</a:t>
+            </a:r>
+            <a:r>
+              <a:rPr lang="de-DE" sz="2000" dirty="0" err="1">
+                <a:solidFill>
+                  <a:srgbClr val="222233"/>
+                </a:solidFill>
+              </a:rPr>
+              <a:t>generation</a:t>
+            </a:r>
+            <a:r>
+              <a:rPr lang="de-DE" sz="2000" dirty="0">
+                <a:solidFill>
+                  <a:srgbClr val="222233"/>
+                </a:solidFill>
+              </a:rPr>
+              <a:t> </a:t>
+            </a:r>
+            <a:r>
+              <a:rPr lang="de-DE" sz="2000" dirty="0" err="1">
+                <a:solidFill>
+                  <a:srgbClr val="222233"/>
+                </a:solidFill>
+              </a:rPr>
+              <a:t>of</a:t>
+            </a:r>
+            <a:r>
+              <a:rPr lang="de-DE" sz="2000" dirty="0">
+                <a:solidFill>
+                  <a:srgbClr val="222233"/>
+                </a:solidFill>
+              </a:rPr>
+              <a:t> </a:t>
+            </a:r>
+            <a:r>
+              <a:rPr lang="de-DE" sz="2000" dirty="0" err="1">
+                <a:solidFill>
+                  <a:srgbClr val="222233"/>
+                </a:solidFill>
+              </a:rPr>
+              <a:t>things</a:t>
+            </a:r>
+            <a:r>
+              <a:rPr lang="de-DE" sz="2000" dirty="0">
+                <a:solidFill>
+                  <a:srgbClr val="222233"/>
+                </a:solidFill>
+              </a:rPr>
+              <a:t> </a:t>
+            </a:r>
+            <a:r>
+              <a:rPr lang="de-DE" sz="2000" dirty="0" err="1">
+                <a:solidFill>
+                  <a:srgbClr val="222233"/>
+                </a:solidFill>
+              </a:rPr>
+              <a:t>that</a:t>
+            </a:r>
+            <a:r>
+              <a:rPr lang="de-DE" sz="2000" dirty="0">
+                <a:solidFill>
+                  <a:srgbClr val="222233"/>
+                </a:solidFill>
+              </a:rPr>
+              <a:t> </a:t>
+            </a:r>
+            <a:r>
+              <a:rPr lang="de-DE" sz="2000" dirty="0" err="1">
+                <a:solidFill>
+                  <a:srgbClr val="222233"/>
+                </a:solidFill>
+              </a:rPr>
+              <a:t>are</a:t>
+            </a:r>
+            <a:r>
+              <a:rPr lang="de-DE" sz="2000" dirty="0">
+                <a:solidFill>
+                  <a:srgbClr val="222233"/>
+                </a:solidFill>
+              </a:rPr>
+              <a:t> </a:t>
+            </a:r>
+            <a:r>
+              <a:rPr lang="de-DE" sz="2000" dirty="0" err="1">
+                <a:solidFill>
+                  <a:srgbClr val="222233"/>
+                </a:solidFill>
+              </a:rPr>
+              <a:t>never</a:t>
+            </a:r>
+            <a:r>
+              <a:rPr lang="de-DE" sz="2000" dirty="0">
+                <a:solidFill>
+                  <a:srgbClr val="222233"/>
+                </a:solidFill>
+              </a:rPr>
+              <a:t> </a:t>
+            </a:r>
+            <a:r>
+              <a:rPr lang="de-DE" sz="2000" dirty="0" err="1">
+                <a:solidFill>
+                  <a:srgbClr val="222233"/>
+                </a:solidFill>
+              </a:rPr>
+              <a:t>used</a:t>
+            </a:r>
+            <a:r>
+              <a:rPr lang="de-DE" sz="2000" dirty="0">
+                <a:solidFill>
+                  <a:srgbClr val="222233"/>
+                </a:solidFill>
+              </a:rPr>
+              <a:t>)</a:t>
+            </a:r>
+          </a:p>
+          <a:p>
+            <a:pPr>
+              <a:spcBef>
+                <a:spcPts val="2000"/>
+              </a:spcBef>
+            </a:pPr>
+            <a:r>
+              <a:rPr lang="de-DE" sz="2000" dirty="0">
+                <a:solidFill>
+                  <a:srgbClr val="222233"/>
+                </a:solidFill>
+              </a:rPr>
+              <a:t> (</a:t>
+            </a:r>
+            <a:r>
+              <a:rPr lang="de-DE" sz="2000" dirty="0" err="1">
+                <a:solidFill>
+                  <a:srgbClr val="222233"/>
+                </a:solidFill>
+              </a:rPr>
+              <a:t>supressing</a:t>
+            </a:r>
+            <a:r>
+              <a:rPr lang="de-DE" sz="2000" dirty="0">
+                <a:solidFill>
+                  <a:srgbClr val="222233"/>
+                </a:solidFill>
+              </a:rPr>
+              <a:t> </a:t>
+            </a:r>
+            <a:r>
+              <a:rPr lang="de-DE" sz="2000" dirty="0" err="1">
+                <a:solidFill>
+                  <a:srgbClr val="222233"/>
+                </a:solidFill>
+              </a:rPr>
+              <a:t>linter</a:t>
+            </a:r>
+            <a:r>
+              <a:rPr lang="de-DE" sz="2000" dirty="0">
+                <a:solidFill>
+                  <a:srgbClr val="222233"/>
+                </a:solidFill>
+              </a:rPr>
+              <a:t>)</a:t>
+            </a:r>
+            <a:endParaRPr sz="2000" dirty="0">
+              <a:solidFill>
+                <a:srgbClr val="222233"/>
+              </a:solidFill>
+            </a:endParaRPr>
           </a:p>
         </p:txBody>
       </p:sp>

</xml_diff>